<commit_message>
Enable explicit credential-free approval for the synthetic judge demo
</commit_message>
<xml_diff>
--- a/docs/TwinOps_Deck.pptx
+++ b/docs/TwinOps_Deck.pptx
@@ -2,43 +2,43 @@
 <file path=ppt/presentation.xml><?xml version="1.0" encoding="utf-8"?>
 <p:presentation xmlns:p="http://schemas.openxmlformats.org/presentationml/2006/main" embedTrueTypeFonts="1" saveSubsetFonts="0">
   <p:sldMasterIdLst>
-    <p:sldMasterId xmlns:r="http://schemas.openxmlformats.org/officeDocument/2006/relationships" id="2147483648" r:id="Rff26502e26444181"/>
+    <p:sldMasterId xmlns:r="http://schemas.openxmlformats.org/officeDocument/2006/relationships" id="2147483648" r:id="Rcfcf3a97db8e4215"/>
   </p:sldMasterIdLst>
   <p:notesMasterIdLst>
-    <p:notesMasterId xmlns:r="http://schemas.openxmlformats.org/officeDocument/2006/relationships" r:id="Rb699ab9956404d7e"/>
+    <p:notesMasterId xmlns:r="http://schemas.openxmlformats.org/officeDocument/2006/relationships" r:id="R2c9ffe99483a4564"/>
   </p:notesMasterIdLst>
   <p:sldIdLst>
-    <p:sldId xmlns:r="http://schemas.openxmlformats.org/officeDocument/2006/relationships" id="256" r:id="Rcb9f2c3483ff49a8"/>
-    <p:sldId xmlns:r="http://schemas.openxmlformats.org/officeDocument/2006/relationships" id="257" r:id="R62326b4ce1914ebf"/>
-    <p:sldId xmlns:r="http://schemas.openxmlformats.org/officeDocument/2006/relationships" id="258" r:id="R56b3241562024c8b"/>
-    <p:sldId xmlns:r="http://schemas.openxmlformats.org/officeDocument/2006/relationships" id="259" r:id="R51812158173b40c6"/>
-    <p:sldId xmlns:r="http://schemas.openxmlformats.org/officeDocument/2006/relationships" id="260" r:id="R6605293bd6104d2e"/>
-    <p:sldId xmlns:r="http://schemas.openxmlformats.org/officeDocument/2006/relationships" id="261" r:id="R56e7910fee944db4"/>
-    <p:sldId xmlns:r="http://schemas.openxmlformats.org/officeDocument/2006/relationships" id="262" r:id="R7f9d34e3ba1c44e2"/>
-    <p:sldId xmlns:r="http://schemas.openxmlformats.org/officeDocument/2006/relationships" id="263" r:id="R0abba83807554b07"/>
-    <p:sldId xmlns:r="http://schemas.openxmlformats.org/officeDocument/2006/relationships" id="264" r:id="Rae8f8686bfda4d66"/>
-    <p:sldId xmlns:r="http://schemas.openxmlformats.org/officeDocument/2006/relationships" id="265" r:id="R1a1a404c260f438b"/>
-    <p:sldId xmlns:r="http://schemas.openxmlformats.org/officeDocument/2006/relationships" id="266" r:id="R1186cdf737d34b7e"/>
-    <p:sldId xmlns:r="http://schemas.openxmlformats.org/officeDocument/2006/relationships" id="267" r:id="Ra573d6aba4374d99"/>
-    <p:sldId xmlns:r="http://schemas.openxmlformats.org/officeDocument/2006/relationships" id="268" r:id="R0d88d05f40e74cba"/>
+    <p:sldId xmlns:r="http://schemas.openxmlformats.org/officeDocument/2006/relationships" id="256" r:id="R4ba4f61f04444378"/>
+    <p:sldId xmlns:r="http://schemas.openxmlformats.org/officeDocument/2006/relationships" id="257" r:id="Red32fb15bbfa4643"/>
+    <p:sldId xmlns:r="http://schemas.openxmlformats.org/officeDocument/2006/relationships" id="258" r:id="R9353009a768d4053"/>
+    <p:sldId xmlns:r="http://schemas.openxmlformats.org/officeDocument/2006/relationships" id="259" r:id="R384ea5d49ed347a2"/>
+    <p:sldId xmlns:r="http://schemas.openxmlformats.org/officeDocument/2006/relationships" id="260" r:id="Rcc9497125c5f49ef"/>
+    <p:sldId xmlns:r="http://schemas.openxmlformats.org/officeDocument/2006/relationships" id="261" r:id="R190c7f9803e44928"/>
+    <p:sldId xmlns:r="http://schemas.openxmlformats.org/officeDocument/2006/relationships" id="262" r:id="Rbb3098afa2074705"/>
+    <p:sldId xmlns:r="http://schemas.openxmlformats.org/officeDocument/2006/relationships" id="263" r:id="Rb7b5d511b8014067"/>
+    <p:sldId xmlns:r="http://schemas.openxmlformats.org/officeDocument/2006/relationships" id="264" r:id="R7838b8890fc54c07"/>
+    <p:sldId xmlns:r="http://schemas.openxmlformats.org/officeDocument/2006/relationships" id="265" r:id="Rd0b94c2fd6184608"/>
+    <p:sldId xmlns:r="http://schemas.openxmlformats.org/officeDocument/2006/relationships" id="266" r:id="R30d93d61945d4224"/>
+    <p:sldId xmlns:r="http://schemas.openxmlformats.org/officeDocument/2006/relationships" id="267" r:id="Rdb7053dca8cb43fb"/>
+    <p:sldId xmlns:r="http://schemas.openxmlformats.org/officeDocument/2006/relationships" id="268" r:id="R67ae2aaf73464a85"/>
   </p:sldIdLst>
   <p:sldSz cx="9144000" cy="5143500"/>
   <p:notesSz cx="6858000" cy="9144000"/>
   <p:embeddedFontLst>
     <p:embeddedFont>
       <p:font typeface="Google Sans Flex Medium"/>
-      <p:regular xmlns:r="http://schemas.openxmlformats.org/officeDocument/2006/relationships" r:id="R0bc1b1bf691543cb"/>
-      <p:bold xmlns:r="http://schemas.openxmlformats.org/officeDocument/2006/relationships" r:id="Rda0fee517a904bf9"/>
+      <p:regular xmlns:r="http://schemas.openxmlformats.org/officeDocument/2006/relationships" r:id="Rbce6171f65c44aa4"/>
+      <p:bold xmlns:r="http://schemas.openxmlformats.org/officeDocument/2006/relationships" r:id="R1923de8c89e843ae"/>
     </p:embeddedFont>
     <p:embeddedFont>
       <p:font typeface="Google Sans Flex"/>
-      <p:regular xmlns:r="http://schemas.openxmlformats.org/officeDocument/2006/relationships" r:id="Re28444c225c247ee"/>
-      <p:bold xmlns:r="http://schemas.openxmlformats.org/officeDocument/2006/relationships" r:id="R6f59c48abe9a4532"/>
+      <p:regular xmlns:r="http://schemas.openxmlformats.org/officeDocument/2006/relationships" r:id="Rede0b7c1b3654fe9"/>
+      <p:bold xmlns:r="http://schemas.openxmlformats.org/officeDocument/2006/relationships" r:id="Re194fb05a44d41f6"/>
     </p:embeddedFont>
     <p:embeddedFont>
       <p:font typeface="Google Sans Flex SemiBold"/>
-      <p:regular xmlns:r="http://schemas.openxmlformats.org/officeDocument/2006/relationships" r:id="R8aadd239d18448f0"/>
-      <p:bold xmlns:r="http://schemas.openxmlformats.org/officeDocument/2006/relationships" r:id="Rf09f08f7261440ea"/>
+      <p:regular xmlns:r="http://schemas.openxmlformats.org/officeDocument/2006/relationships" r:id="R128976234d40403f"/>
+      <p:bold xmlns:r="http://schemas.openxmlformats.org/officeDocument/2006/relationships" r:id="Recbcd7b8b6604b37"/>
     </p:embeddedFont>
   </p:embeddedFontLst>
   <p:defaultTextStyle>
@@ -973,7 +973,7 @@
               <a:buNone/>
             </a:pPr>
             <a:r>
-              <a:t>Public links checked on 16 October 2026. The current public video preserves the hosted repair described in this presentation. Waiting and review time are shortened. Approval access is provided privately by the project host; no credential is included in this deck.</a:t>
+              <a:t>Public links checked on 16 October 2026. The current public video preserves the hosted repair described in this presentation. Waiting and review time are shortened. Public demo approval requires no passcode. The disabled field contains only placeholder dots. The operator reviews evidence and explicitly approves the synthetic lab change. Protected deployments require server-side credentials.</a:t>
             </a:r>
             <a:endParaRPr/>
           </a:p>
@@ -1741,7 +1741,7 @@
           <p:cNvPr id="10" name="Google Shape;10;p2">
             <a:extLst xmlns:a="http://schemas.openxmlformats.org/drawingml/2006/main">
               <a:ext uri="{FF2B5EF4-FFF2-40B4-BE49-F238E27FC236}">
-                <a16:creationId xmlns:a16="http://schemas.microsoft.com/office/drawing/2014/main" id="{77DE86CC-2D47-4876-A1BF-774CB36196EB}"/>
+                <a16:creationId xmlns:a16="http://schemas.microsoft.com/office/drawing/2014/main" id="{C5A082AE-1356-4F39-AA4C-C935B5B50F10}"/>
               </a:ext>
             </a:extLst>
           </p:cNvPr>
@@ -1874,7 +1874,7 @@
           <p:cNvPr id="11" name="Google Shape;11;p2">
             <a:extLst xmlns:a="http://schemas.openxmlformats.org/drawingml/2006/main">
               <a:ext uri="{FF2B5EF4-FFF2-40B4-BE49-F238E27FC236}">
-                <a16:creationId xmlns:a16="http://schemas.microsoft.com/office/drawing/2014/main" id="{F7A97BD8-6762-4BF7-8BAB-3FD974AE26D1}"/>
+                <a16:creationId xmlns:a16="http://schemas.microsoft.com/office/drawing/2014/main" id="{5A7CF486-A40F-4670-8508-5CA3C53C3E03}"/>
               </a:ext>
             </a:extLst>
           </p:cNvPr>
@@ -2034,7 +2034,7 @@
           <p:cNvPr id="12" name="Google Shape;12;p2">
             <a:extLst xmlns:a="http://schemas.openxmlformats.org/drawingml/2006/main">
               <a:ext uri="{FF2B5EF4-FFF2-40B4-BE49-F238E27FC236}">
-                <a16:creationId xmlns:a16="http://schemas.microsoft.com/office/drawing/2014/main" id="{2B9EAB2D-041E-476D-83E6-DE7AC8F6FAAB}"/>
+                <a16:creationId xmlns:a16="http://schemas.microsoft.com/office/drawing/2014/main" id="{81A38053-20C1-440B-9966-F002514A68CF}"/>
               </a:ext>
             </a:extLst>
           </p:cNvPr>
@@ -2135,7 +2135,7 @@
           <p:cNvPr id="45" name="Google Shape;45;p11">
             <a:extLst xmlns:a="http://schemas.openxmlformats.org/drawingml/2006/main">
               <a:ext uri="{FF2B5EF4-FFF2-40B4-BE49-F238E27FC236}">
-                <a16:creationId xmlns:a16="http://schemas.microsoft.com/office/drawing/2014/main" id="{7A1391DF-7A1C-4937-A078-79D5500A5606}"/>
+                <a16:creationId xmlns:a16="http://schemas.microsoft.com/office/drawing/2014/main" id="{BADB5C7E-5844-4C09-929B-A9C5EB078CC2}"/>
               </a:ext>
             </a:extLst>
           </p:cNvPr>
@@ -2272,7 +2272,7 @@
           <p:cNvPr id="46" name="Google Shape;46;p11">
             <a:extLst xmlns:a="http://schemas.openxmlformats.org/drawingml/2006/main">
               <a:ext uri="{FF2B5EF4-FFF2-40B4-BE49-F238E27FC236}">
-                <a16:creationId xmlns:a16="http://schemas.microsoft.com/office/drawing/2014/main" id="{42C926DF-CB5B-4786-BF08-09B84AE5DF18}"/>
+                <a16:creationId xmlns:a16="http://schemas.microsoft.com/office/drawing/2014/main" id="{7C6CAEB9-8009-4518-A73F-0C5A30DEE5F4}"/>
               </a:ext>
             </a:extLst>
           </p:cNvPr>
@@ -2405,7 +2405,7 @@
           <p:cNvPr id="47" name="Google Shape;47;p11">
             <a:extLst xmlns:a="http://schemas.openxmlformats.org/drawingml/2006/main">
               <a:ext uri="{FF2B5EF4-FFF2-40B4-BE49-F238E27FC236}">
-                <a16:creationId xmlns:a16="http://schemas.microsoft.com/office/drawing/2014/main" id="{5C200199-83A6-43C1-B978-DC2AD947EA84}"/>
+                <a16:creationId xmlns:a16="http://schemas.microsoft.com/office/drawing/2014/main" id="{DE7E80A5-E261-475F-9D71-8B92391D130C}"/>
               </a:ext>
             </a:extLst>
           </p:cNvPr>
@@ -2506,7 +2506,7 @@
           <p:cNvPr id="49" name="Google Shape;49;p12">
             <a:extLst xmlns:a="http://schemas.openxmlformats.org/drawingml/2006/main">
               <a:ext uri="{FF2B5EF4-FFF2-40B4-BE49-F238E27FC236}">
-                <a16:creationId xmlns:a16="http://schemas.microsoft.com/office/drawing/2014/main" id="{B8AF0AD0-F89B-41F4-9006-49CB151C958A}"/>
+                <a16:creationId xmlns:a16="http://schemas.microsoft.com/office/drawing/2014/main" id="{A5B49CD5-B9FB-41DC-B969-246BC6C8AB08}"/>
               </a:ext>
             </a:extLst>
           </p:cNvPr>
@@ -2607,7 +2607,7 @@
           <p:cNvPr id="14" name="Google Shape;14;p3">
             <a:extLst xmlns:a="http://schemas.openxmlformats.org/drawingml/2006/main">
               <a:ext uri="{FF2B5EF4-FFF2-40B4-BE49-F238E27FC236}">
-                <a16:creationId xmlns:a16="http://schemas.microsoft.com/office/drawing/2014/main" id="{2D1B3DE1-D337-4677-8543-098B876F0F51}"/>
+                <a16:creationId xmlns:a16="http://schemas.microsoft.com/office/drawing/2014/main" id="{221564D6-50A4-488B-A5E9-FAF1095C1A06}"/>
               </a:ext>
             </a:extLst>
           </p:cNvPr>
@@ -2740,7 +2740,7 @@
           <p:cNvPr id="15" name="Google Shape;15;p3">
             <a:extLst xmlns:a="http://schemas.openxmlformats.org/drawingml/2006/main">
               <a:ext uri="{FF2B5EF4-FFF2-40B4-BE49-F238E27FC236}">
-                <a16:creationId xmlns:a16="http://schemas.microsoft.com/office/drawing/2014/main" id="{293E9EF0-C9FB-4503-89E3-D930CDF2DE64}"/>
+                <a16:creationId xmlns:a16="http://schemas.microsoft.com/office/drawing/2014/main" id="{C84C3E95-439B-4AEC-9687-71062B4FA07F}"/>
               </a:ext>
             </a:extLst>
           </p:cNvPr>
@@ -2841,7 +2841,7 @@
           <p:cNvPr id="17" name="Google Shape;17;p4">
             <a:extLst xmlns:a="http://schemas.openxmlformats.org/drawingml/2006/main">
               <a:ext uri="{FF2B5EF4-FFF2-40B4-BE49-F238E27FC236}">
-                <a16:creationId xmlns:a16="http://schemas.microsoft.com/office/drawing/2014/main" id="{52695196-BD29-4F84-87EC-256FFC78C771}"/>
+                <a16:creationId xmlns:a16="http://schemas.microsoft.com/office/drawing/2014/main" id="{FDCC13D5-A48A-4049-94B4-3E520F9D680B}"/>
               </a:ext>
             </a:extLst>
           </p:cNvPr>
@@ -2974,7 +2974,7 @@
           <p:cNvPr id="18" name="Google Shape;18;p4">
             <a:extLst xmlns:a="http://schemas.openxmlformats.org/drawingml/2006/main">
               <a:ext uri="{FF2B5EF4-FFF2-40B4-BE49-F238E27FC236}">
-                <a16:creationId xmlns:a16="http://schemas.microsoft.com/office/drawing/2014/main" id="{D27AD551-EB81-4A7C-97A1-EEC7505D5C36}"/>
+                <a16:creationId xmlns:a16="http://schemas.microsoft.com/office/drawing/2014/main" id="{C30E29BB-9CE2-48E6-BD25-FA27FA4127A8}"/>
               </a:ext>
             </a:extLst>
           </p:cNvPr>
@@ -3107,7 +3107,7 @@
           <p:cNvPr id="19" name="Google Shape;19;p4">
             <a:extLst xmlns:a="http://schemas.openxmlformats.org/drawingml/2006/main">
               <a:ext uri="{FF2B5EF4-FFF2-40B4-BE49-F238E27FC236}">
-                <a16:creationId xmlns:a16="http://schemas.microsoft.com/office/drawing/2014/main" id="{96E396D0-8A17-4D32-AFC5-255EFED3C8B1}"/>
+                <a16:creationId xmlns:a16="http://schemas.microsoft.com/office/drawing/2014/main" id="{9B5CEA02-4F1A-4536-AF5A-802A5C106945}"/>
               </a:ext>
             </a:extLst>
           </p:cNvPr>
@@ -3208,7 +3208,7 @@
           <p:cNvPr id="21" name="Google Shape;21;p5">
             <a:extLst xmlns:a="http://schemas.openxmlformats.org/drawingml/2006/main">
               <a:ext uri="{FF2B5EF4-FFF2-40B4-BE49-F238E27FC236}">
-                <a16:creationId xmlns:a16="http://schemas.microsoft.com/office/drawing/2014/main" id="{FCDEF8AA-4F98-496D-9A2C-9E3369BB511A}"/>
+                <a16:creationId xmlns:a16="http://schemas.microsoft.com/office/drawing/2014/main" id="{DE4CED03-AECE-46CF-8104-0F75DBA4D6E5}"/>
               </a:ext>
             </a:extLst>
           </p:cNvPr>
@@ -3341,7 +3341,7 @@
           <p:cNvPr id="22" name="Google Shape;22;p5">
             <a:extLst xmlns:a="http://schemas.openxmlformats.org/drawingml/2006/main">
               <a:ext uri="{FF2B5EF4-FFF2-40B4-BE49-F238E27FC236}">
-                <a16:creationId xmlns:a16="http://schemas.microsoft.com/office/drawing/2014/main" id="{B6822A04-76DE-4938-8153-84E876FCB0D9}"/>
+                <a16:creationId xmlns:a16="http://schemas.microsoft.com/office/drawing/2014/main" id="{441ED53D-6DDB-45AF-AD73-C25166A56105}"/>
               </a:ext>
             </a:extLst>
           </p:cNvPr>
@@ -3474,7 +3474,7 @@
           <p:cNvPr id="23" name="Google Shape;23;p5">
             <a:extLst xmlns:a="http://schemas.openxmlformats.org/drawingml/2006/main">
               <a:ext uri="{FF2B5EF4-FFF2-40B4-BE49-F238E27FC236}">
-                <a16:creationId xmlns:a16="http://schemas.microsoft.com/office/drawing/2014/main" id="{FD0E2430-5E2B-4CB4-9F00-D97B5E34B2A7}"/>
+                <a16:creationId xmlns:a16="http://schemas.microsoft.com/office/drawing/2014/main" id="{52BF1B03-B189-4594-8A52-C6118DDF191C}"/>
               </a:ext>
             </a:extLst>
           </p:cNvPr>
@@ -3607,7 +3607,7 @@
           <p:cNvPr id="24" name="Google Shape;24;p5">
             <a:extLst xmlns:a="http://schemas.openxmlformats.org/drawingml/2006/main">
               <a:ext uri="{FF2B5EF4-FFF2-40B4-BE49-F238E27FC236}">
-                <a16:creationId xmlns:a16="http://schemas.microsoft.com/office/drawing/2014/main" id="{822A973B-210F-4BA7-9FC2-AA10CDFCA672}"/>
+                <a16:creationId xmlns:a16="http://schemas.microsoft.com/office/drawing/2014/main" id="{3BC0B745-1ECB-4933-A95D-EBEB2768BAFF}"/>
               </a:ext>
             </a:extLst>
           </p:cNvPr>
@@ -3708,7 +3708,7 @@
           <p:cNvPr id="26" name="Google Shape;26;p6">
             <a:extLst xmlns:a="http://schemas.openxmlformats.org/drawingml/2006/main">
               <a:ext uri="{FF2B5EF4-FFF2-40B4-BE49-F238E27FC236}">
-                <a16:creationId xmlns:a16="http://schemas.microsoft.com/office/drawing/2014/main" id="{190F2E9B-0107-4351-84E8-C2F63F3D77D5}"/>
+                <a16:creationId xmlns:a16="http://schemas.microsoft.com/office/drawing/2014/main" id="{35AAE6FC-48F5-4B4E-B77F-060B15C54E2A}"/>
               </a:ext>
             </a:extLst>
           </p:cNvPr>
@@ -3841,7 +3841,7 @@
           <p:cNvPr id="27" name="Google Shape;27;p6">
             <a:extLst xmlns:a="http://schemas.openxmlformats.org/drawingml/2006/main">
               <a:ext uri="{FF2B5EF4-FFF2-40B4-BE49-F238E27FC236}">
-                <a16:creationId xmlns:a16="http://schemas.microsoft.com/office/drawing/2014/main" id="{5CBB9E80-495C-40E2-BAAC-CCFD2D74FD64}"/>
+                <a16:creationId xmlns:a16="http://schemas.microsoft.com/office/drawing/2014/main" id="{F25DFCB9-22E0-4F7F-AE01-0568825C249C}"/>
               </a:ext>
             </a:extLst>
           </p:cNvPr>
@@ -3942,7 +3942,7 @@
           <p:cNvPr id="29" name="Google Shape;29;p7">
             <a:extLst xmlns:a="http://schemas.openxmlformats.org/drawingml/2006/main">
               <a:ext uri="{FF2B5EF4-FFF2-40B4-BE49-F238E27FC236}">
-                <a16:creationId xmlns:a16="http://schemas.microsoft.com/office/drawing/2014/main" id="{EB97CE41-11A0-41B9-96EA-F7EEA44E2F15}"/>
+                <a16:creationId xmlns:a16="http://schemas.microsoft.com/office/drawing/2014/main" id="{F900CAF5-48F4-4765-9D78-004E71BD55B4}"/>
               </a:ext>
             </a:extLst>
           </p:cNvPr>
@@ -4075,7 +4075,7 @@
           <p:cNvPr id="30" name="Google Shape;30;p7">
             <a:extLst xmlns:a="http://schemas.openxmlformats.org/drawingml/2006/main">
               <a:ext uri="{FF2B5EF4-FFF2-40B4-BE49-F238E27FC236}">
-                <a16:creationId xmlns:a16="http://schemas.microsoft.com/office/drawing/2014/main" id="{AB5319A6-A434-4175-91B2-26827758A40A}"/>
+                <a16:creationId xmlns:a16="http://schemas.microsoft.com/office/drawing/2014/main" id="{48137A66-D5EB-4B1F-AE3E-DD5DDF8A6382}"/>
               </a:ext>
             </a:extLst>
           </p:cNvPr>
@@ -4208,7 +4208,7 @@
           <p:cNvPr id="31" name="Google Shape;31;p7">
             <a:extLst xmlns:a="http://schemas.openxmlformats.org/drawingml/2006/main">
               <a:ext uri="{FF2B5EF4-FFF2-40B4-BE49-F238E27FC236}">
-                <a16:creationId xmlns:a16="http://schemas.microsoft.com/office/drawing/2014/main" id="{312E6B44-E648-4E90-88A1-07D003D021D6}"/>
+                <a16:creationId xmlns:a16="http://schemas.microsoft.com/office/drawing/2014/main" id="{ADA65D60-80A3-4D89-8F10-4FF4341BFAD7}"/>
               </a:ext>
             </a:extLst>
           </p:cNvPr>
@@ -4309,7 +4309,7 @@
           <p:cNvPr id="33" name="Google Shape;33;p8">
             <a:extLst xmlns:a="http://schemas.openxmlformats.org/drawingml/2006/main">
               <a:ext uri="{FF2B5EF4-FFF2-40B4-BE49-F238E27FC236}">
-                <a16:creationId xmlns:a16="http://schemas.microsoft.com/office/drawing/2014/main" id="{D510D12E-B427-446B-826C-DD0BE9703175}"/>
+                <a16:creationId xmlns:a16="http://schemas.microsoft.com/office/drawing/2014/main" id="{3214F6DB-7993-4758-9991-99A66B0B1AB5}"/>
               </a:ext>
             </a:extLst>
           </p:cNvPr>
@@ -4442,7 +4442,7 @@
           <p:cNvPr id="34" name="Google Shape;34;p8">
             <a:extLst xmlns:a="http://schemas.openxmlformats.org/drawingml/2006/main">
               <a:ext uri="{FF2B5EF4-FFF2-40B4-BE49-F238E27FC236}">
-                <a16:creationId xmlns:a16="http://schemas.microsoft.com/office/drawing/2014/main" id="{4345CEB1-F07B-4BC1-906E-12FA4473EEAE}"/>
+                <a16:creationId xmlns:a16="http://schemas.microsoft.com/office/drawing/2014/main" id="{6E195B98-EE9E-430E-A45E-A2552E8AA7A0}"/>
               </a:ext>
             </a:extLst>
           </p:cNvPr>
@@ -4543,7 +4543,7 @@
           <p:cNvPr id="36" name="Google Shape;36;p9">
             <a:extLst xmlns:a="http://schemas.openxmlformats.org/drawingml/2006/main">
               <a:ext uri="{FF2B5EF4-FFF2-40B4-BE49-F238E27FC236}">
-                <a16:creationId xmlns:a16="http://schemas.microsoft.com/office/drawing/2014/main" id="{3BDB8363-D20A-405F-95E7-AD27BC312B5D}"/>
+                <a16:creationId xmlns:a16="http://schemas.microsoft.com/office/drawing/2014/main" id="{ECB80C5D-CD1D-4EFA-8F05-905C5F8B85A8}"/>
               </a:ext>
             </a:extLst>
           </p:cNvPr>
@@ -4594,7 +4594,7 @@
           <p:cNvPr id="37" name="Google Shape;37;p9">
             <a:extLst xmlns:a="http://schemas.openxmlformats.org/drawingml/2006/main">
               <a:ext uri="{FF2B5EF4-FFF2-40B4-BE49-F238E27FC236}">
-                <a16:creationId xmlns:a16="http://schemas.microsoft.com/office/drawing/2014/main" id="{3991308F-BD6A-41BD-8FFF-5C399C9B6A5E}"/>
+                <a16:creationId xmlns:a16="http://schemas.microsoft.com/office/drawing/2014/main" id="{AEDADFF3-976A-468F-ACE9-64B874D29A6E}"/>
               </a:ext>
             </a:extLst>
           </p:cNvPr>
@@ -4727,7 +4727,7 @@
           <p:cNvPr id="38" name="Google Shape;38;p9">
             <a:extLst xmlns:a="http://schemas.openxmlformats.org/drawingml/2006/main">
               <a:ext uri="{FF2B5EF4-FFF2-40B4-BE49-F238E27FC236}">
-                <a16:creationId xmlns:a16="http://schemas.microsoft.com/office/drawing/2014/main" id="{EF9B6962-13C6-459D-BC57-411EC21B8A3C}"/>
+                <a16:creationId xmlns:a16="http://schemas.microsoft.com/office/drawing/2014/main" id="{F43DBD47-9881-42EE-8AAD-DB6B96B8C168}"/>
               </a:ext>
             </a:extLst>
           </p:cNvPr>
@@ -4887,7 +4887,7 @@
           <p:cNvPr id="39" name="Google Shape;39;p9">
             <a:extLst xmlns:a="http://schemas.openxmlformats.org/drawingml/2006/main">
               <a:ext uri="{FF2B5EF4-FFF2-40B4-BE49-F238E27FC236}">
-                <a16:creationId xmlns:a16="http://schemas.microsoft.com/office/drawing/2014/main" id="{8FD0042E-AB52-4FB3-870E-18556AFF19E0}"/>
+                <a16:creationId xmlns:a16="http://schemas.microsoft.com/office/drawing/2014/main" id="{4C93BBFB-38ED-45FE-AB29-C5F37BBC14C5}"/>
               </a:ext>
             </a:extLst>
           </p:cNvPr>
@@ -5020,7 +5020,7 @@
           <p:cNvPr id="40" name="Google Shape;40;p9">
             <a:extLst xmlns:a="http://schemas.openxmlformats.org/drawingml/2006/main">
               <a:ext uri="{FF2B5EF4-FFF2-40B4-BE49-F238E27FC236}">
-                <a16:creationId xmlns:a16="http://schemas.microsoft.com/office/drawing/2014/main" id="{64BC1D1B-142A-42D1-A985-4CBE08CA24A2}"/>
+                <a16:creationId xmlns:a16="http://schemas.microsoft.com/office/drawing/2014/main" id="{0B60F54C-F511-4D2F-8626-46707E670004}"/>
               </a:ext>
             </a:extLst>
           </p:cNvPr>
@@ -5121,7 +5121,7 @@
           <p:cNvPr id="42" name="Google Shape;42;p10">
             <a:extLst xmlns:a="http://schemas.openxmlformats.org/drawingml/2006/main">
               <a:ext uri="{FF2B5EF4-FFF2-40B4-BE49-F238E27FC236}">
-                <a16:creationId xmlns:a16="http://schemas.microsoft.com/office/drawing/2014/main" id="{04CCB19C-FF85-44B6-886F-6A14AB0B883B}"/>
+                <a16:creationId xmlns:a16="http://schemas.microsoft.com/office/drawing/2014/main" id="{3219F4EC-0889-464C-93C8-0F1D62E09757}"/>
               </a:ext>
             </a:extLst>
           </p:cNvPr>
@@ -5169,7 +5169,7 @@
           <p:cNvPr id="43" name="Google Shape;43;p10">
             <a:extLst xmlns:a="http://schemas.openxmlformats.org/drawingml/2006/main">
               <a:ext uri="{FF2B5EF4-FFF2-40B4-BE49-F238E27FC236}">
-                <a16:creationId xmlns:a16="http://schemas.microsoft.com/office/drawing/2014/main" id="{1F003DA0-20EA-4054-9348-F94D8C622CBB}"/>
+                <a16:creationId xmlns:a16="http://schemas.microsoft.com/office/drawing/2014/main" id="{46EE6DC2-410E-4788-9727-A8B55E553253}"/>
               </a:ext>
             </a:extLst>
           </p:cNvPr>
@@ -5277,7 +5277,7 @@
           <p:cNvPr id="6" name="Google Shape;6;p1">
             <a:extLst xmlns:a="http://schemas.openxmlformats.org/drawingml/2006/main">
               <a:ext uri="{FF2B5EF4-FFF2-40B4-BE49-F238E27FC236}">
-                <a16:creationId xmlns:a16="http://schemas.microsoft.com/office/drawing/2014/main" id="{3953EF0E-7630-4711-9813-1B8E4E24185C}"/>
+                <a16:creationId xmlns:a16="http://schemas.microsoft.com/office/drawing/2014/main" id="{85558EC1-8EC7-45DA-8CA7-C4FB92289379}"/>
               </a:ext>
             </a:extLst>
           </p:cNvPr>
@@ -5477,7 +5477,7 @@
           <p:cNvPr id="7" name="Google Shape;7;p1">
             <a:extLst xmlns:a="http://schemas.openxmlformats.org/drawingml/2006/main">
               <a:ext uri="{FF2B5EF4-FFF2-40B4-BE49-F238E27FC236}">
-                <a16:creationId xmlns:a16="http://schemas.microsoft.com/office/drawing/2014/main" id="{EA3D832F-2F0E-4AC1-97A9-9A950B3EF989}"/>
+                <a16:creationId xmlns:a16="http://schemas.microsoft.com/office/drawing/2014/main" id="{F74331ED-4075-4515-99A4-31917C377D2E}"/>
               </a:ext>
             </a:extLst>
           </p:cNvPr>
@@ -5704,7 +5704,7 @@
           <p:cNvPr id="8" name="Google Shape;8;p1">
             <a:extLst xmlns:a="http://schemas.openxmlformats.org/drawingml/2006/main">
               <a:ext uri="{FF2B5EF4-FFF2-40B4-BE49-F238E27FC236}">
-                <a16:creationId xmlns:a16="http://schemas.microsoft.com/office/drawing/2014/main" id="{9C2AAB94-41DF-4EEB-9E58-B61C6D7B5DD2}"/>
+                <a16:creationId xmlns:a16="http://schemas.microsoft.com/office/drawing/2014/main" id="{571C8A8E-748A-4AA2-B3EE-8B3B6948983F}"/>
               </a:ext>
             </a:extLst>
           </p:cNvPr>
@@ -5827,17 +5827,17 @@
   </p:cSld>
   <p:clrMap bg1="lt1" tx1="dk1" bg2="dk2" tx2="lt2" accent1="accent1" accent2="accent2" accent3="accent3" accent4="accent4" accent5="accent5" accent6="accent6" hlink="hlink" folHlink="folHlink"/>
   <p:sldLayoutIdLst>
-    <p:sldLayoutId xmlns:r="http://schemas.openxmlformats.org/officeDocument/2006/relationships" id="2147483649" r:id="Rd45bb3b69a7a4479"/>
-    <p:sldLayoutId xmlns:r="http://schemas.openxmlformats.org/officeDocument/2006/relationships" id="2147483650" r:id="R35fcd0cc3f7f4215"/>
-    <p:sldLayoutId xmlns:r="http://schemas.openxmlformats.org/officeDocument/2006/relationships" id="2147483651" r:id="R99a9a521ee4c4e5c"/>
-    <p:sldLayoutId xmlns:r="http://schemas.openxmlformats.org/officeDocument/2006/relationships" id="2147483652" r:id="Rc963109e6d9b4df8"/>
-    <p:sldLayoutId xmlns:r="http://schemas.openxmlformats.org/officeDocument/2006/relationships" id="2147483653" r:id="Rf3090baa6e494be1"/>
-    <p:sldLayoutId xmlns:r="http://schemas.openxmlformats.org/officeDocument/2006/relationships" id="2147483654" r:id="R8ca06620e763422c"/>
-    <p:sldLayoutId xmlns:r="http://schemas.openxmlformats.org/officeDocument/2006/relationships" id="2147483655" r:id="R388d37720b264c20"/>
-    <p:sldLayoutId xmlns:r="http://schemas.openxmlformats.org/officeDocument/2006/relationships" id="2147483656" r:id="Reec87663ab02414c"/>
-    <p:sldLayoutId xmlns:r="http://schemas.openxmlformats.org/officeDocument/2006/relationships" id="2147483657" r:id="Ree1c1e76c165408b"/>
-    <p:sldLayoutId xmlns:r="http://schemas.openxmlformats.org/officeDocument/2006/relationships" id="2147483658" r:id="Red073f3bd8684d75"/>
-    <p:sldLayoutId xmlns:r="http://schemas.openxmlformats.org/officeDocument/2006/relationships" id="2147483659" r:id="R986065fcc0fb416d"/>
+    <p:sldLayoutId xmlns:r="http://schemas.openxmlformats.org/officeDocument/2006/relationships" id="2147483649" r:id="Rd4d28e839769489e"/>
+    <p:sldLayoutId xmlns:r="http://schemas.openxmlformats.org/officeDocument/2006/relationships" id="2147483650" r:id="Rce7ad6837e964abf"/>
+    <p:sldLayoutId xmlns:r="http://schemas.openxmlformats.org/officeDocument/2006/relationships" id="2147483651" r:id="R1e757b7a7d8842ce"/>
+    <p:sldLayoutId xmlns:r="http://schemas.openxmlformats.org/officeDocument/2006/relationships" id="2147483652" r:id="R36f6594794114a50"/>
+    <p:sldLayoutId xmlns:r="http://schemas.openxmlformats.org/officeDocument/2006/relationships" id="2147483653" r:id="Re21542b15f634bd9"/>
+    <p:sldLayoutId xmlns:r="http://schemas.openxmlformats.org/officeDocument/2006/relationships" id="2147483654" r:id="Re3c55c20151e4342"/>
+    <p:sldLayoutId xmlns:r="http://schemas.openxmlformats.org/officeDocument/2006/relationships" id="2147483655" r:id="Rb9ad503ed38b4d08"/>
+    <p:sldLayoutId xmlns:r="http://schemas.openxmlformats.org/officeDocument/2006/relationships" id="2147483656" r:id="Rf2f25fe4cc224c54"/>
+    <p:sldLayoutId xmlns:r="http://schemas.openxmlformats.org/officeDocument/2006/relationships" id="2147483657" r:id="R34c413015de94f3a"/>
+    <p:sldLayoutId xmlns:r="http://schemas.openxmlformats.org/officeDocument/2006/relationships" id="2147483658" r:id="R01b9e9381ab6422f"/>
+    <p:sldLayoutId xmlns:r="http://schemas.openxmlformats.org/officeDocument/2006/relationships" id="2147483659" r:id="Rf1a4d052d91943c3"/>
   </p:sldLayoutIdLst>
   <p:hf sldNum="0" hdr="0" ftr="0" dt="0"/>
   <p:txStyles>
@@ -6784,7 +6784,7 @@
           <p:cNvPr id="54" name="Google Shape;54;p13">
             <a:extLst xmlns:a="http://schemas.openxmlformats.org/drawingml/2006/main">
               <a:ext uri="{FF2B5EF4-FFF2-40B4-BE49-F238E27FC236}">
-                <a16:creationId xmlns:a16="http://schemas.microsoft.com/office/drawing/2014/main" id="{BEACF300-B400-4F2E-B8B1-4698603ACC86}"/>
+                <a16:creationId xmlns:a16="http://schemas.microsoft.com/office/drawing/2014/main" id="{07325ACE-7356-40E1-A1D8-8F18E0729A89}"/>
               </a:ext>
             </a:extLst>
           </p:cNvPr>
@@ -6864,7 +6864,7 @@
           <p:cNvPr id="55" name="Google Shape;55;p13">
             <a:extLst xmlns:a="http://schemas.openxmlformats.org/drawingml/2006/main">
               <a:ext uri="{FF2B5EF4-FFF2-40B4-BE49-F238E27FC236}">
-                <a16:creationId xmlns:a16="http://schemas.microsoft.com/office/drawing/2014/main" id="{72B3D496-987A-49BA-8471-B979DEE506DD}"/>
+                <a16:creationId xmlns:a16="http://schemas.microsoft.com/office/drawing/2014/main" id="{593CD7CC-7EDD-4550-898B-9C746876214A}"/>
               </a:ext>
             </a:extLst>
           </p:cNvPr>
@@ -6874,7 +6874,7 @@
           <p:nvPr/>
         </p:nvPicPr>
         <p:blipFill>
-          <a:blip xmlns:r="http://schemas.openxmlformats.org/officeDocument/2006/relationships" xmlns:a="http://schemas.openxmlformats.org/drawingml/2006/main" r:embed="Rd61db4cd146944b8">
+          <a:blip xmlns:r="http://schemas.openxmlformats.org/officeDocument/2006/relationships" xmlns:a="http://schemas.openxmlformats.org/drawingml/2006/main" r:embed="Rd9366073600e42d2">
             <a:alphaModFix/>
           </a:blip>
           <a:stretch xmlns:a="http://schemas.openxmlformats.org/drawingml/2006/main">
@@ -6899,7 +6899,7 @@
           <p:cNvPr id="56" name="Google Shape;56;p13">
             <a:extLst xmlns:a="http://schemas.openxmlformats.org/drawingml/2006/main">
               <a:ext uri="{FF2B5EF4-FFF2-40B4-BE49-F238E27FC236}">
-                <a16:creationId xmlns:a16="http://schemas.microsoft.com/office/drawing/2014/main" id="{94D66FA3-2C9F-49DB-9B3E-56576063BC1E}"/>
+                <a16:creationId xmlns:a16="http://schemas.microsoft.com/office/drawing/2014/main" id="{EC99C47E-053D-420E-AEE7-61E415D0F4EB}"/>
               </a:ext>
             </a:extLst>
           </p:cNvPr>
@@ -6909,7 +6909,7 @@
           <p:nvPr/>
         </p:nvPicPr>
         <p:blipFill rotWithShape="1">
-          <a:blip xmlns:r="http://schemas.openxmlformats.org/officeDocument/2006/relationships" xmlns:a="http://schemas.openxmlformats.org/drawingml/2006/main" r:embed="Raafb277776164f05">
+          <a:blip xmlns:r="http://schemas.openxmlformats.org/officeDocument/2006/relationships" xmlns:a="http://schemas.openxmlformats.org/drawingml/2006/main" r:embed="R9e4d6502fbd0421f">
             <a:alphaModFix/>
           </a:blip>
           <a:srcRect xmlns:a="http://schemas.openxmlformats.org/drawingml/2006/main" l="0" t="0" r="0" b="98001"/>
@@ -6933,7 +6933,7 @@
           <p:cNvPr id="57" name="cover-product">
             <a:extLst xmlns:a="http://schemas.openxmlformats.org/drawingml/2006/main">
               <a:ext uri="{FF2B5EF4-FFF2-40B4-BE49-F238E27FC236}">
-                <a16:creationId xmlns:a16="http://schemas.microsoft.com/office/drawing/2014/main" id="{4034098B-01BA-41B2-A5B7-4F9F47173573}"/>
+                <a16:creationId xmlns:a16="http://schemas.microsoft.com/office/drawing/2014/main" id="{F48E9FD2-F368-4C9B-B968-6B4EDCC60D6D}"/>
               </a:ext>
             </a:extLst>
           </p:cNvPr>
@@ -7001,7 +7001,7 @@
           <p:cNvPr id="58" name="cover-definition">
             <a:extLst xmlns:a="http://schemas.openxmlformats.org/drawingml/2006/main">
               <a:ext uri="{FF2B5EF4-FFF2-40B4-BE49-F238E27FC236}">
-                <a16:creationId xmlns:a16="http://schemas.microsoft.com/office/drawing/2014/main" id="{1D5044C4-64CF-42DB-9D53-212C8FBEEE02}"/>
+                <a16:creationId xmlns:a16="http://schemas.microsoft.com/office/drawing/2014/main" id="{27C30463-8948-462C-AE33-82A1512078C4}"/>
               </a:ext>
             </a:extLst>
           </p:cNvPr>
@@ -7069,7 +7069,7 @@
           <p:cNvPr id="59" name="registered-team">
             <a:extLst xmlns:a="http://schemas.openxmlformats.org/drawingml/2006/main">
               <a:ext uri="{FF2B5EF4-FFF2-40B4-BE49-F238E27FC236}">
-                <a16:creationId xmlns:a16="http://schemas.microsoft.com/office/drawing/2014/main" id="{7107381B-B0C3-44C3-8D25-118FFB418E74}"/>
+                <a16:creationId xmlns:a16="http://schemas.microsoft.com/office/drawing/2014/main" id="{2FBBFC9F-4CB1-4938-A733-C9B5AB5D2D03}"/>
               </a:ext>
             </a:extLst>
           </p:cNvPr>
@@ -7137,7 +7137,7 @@
           <p:cNvPr id="60" name="theme">
             <a:extLst xmlns:a="http://schemas.openxmlformats.org/drawingml/2006/main">
               <a:ext uri="{FF2B5EF4-FFF2-40B4-BE49-F238E27FC236}">
-                <a16:creationId xmlns:a16="http://schemas.microsoft.com/office/drawing/2014/main" id="{4CB50820-38C4-4820-934D-0579156CD04A}"/>
+                <a16:creationId xmlns:a16="http://schemas.microsoft.com/office/drawing/2014/main" id="{B142998C-BA1B-4ADA-BF56-B7294F7E3CDD}"/>
               </a:ext>
             </a:extLst>
           </p:cNvPr>
@@ -7203,7 +7203,7 @@
     </p:spTree>
     <p:extLst>
       <p:ext uri="{BB962C8B-B14F-4D97-AF65-F5344CB8AC3E}">
-        <p14:creationId xmlns:p14="http://schemas.microsoft.com/office/powerpoint/2010/main" val="819847265"/>
+        <p14:creationId xmlns:p14="http://schemas.microsoft.com/office/powerpoint/2010/main" val="1845843691"/>
       </p:ext>
     </p:extLst>
   </p:cSld>
@@ -7227,7 +7227,7 @@
           <p:cNvPr id="140" name="Google Shape;140;p24">
             <a:extLst xmlns:a="http://schemas.openxmlformats.org/drawingml/2006/main">
               <a:ext uri="{FF2B5EF4-FFF2-40B4-BE49-F238E27FC236}">
-                <a16:creationId xmlns:a16="http://schemas.microsoft.com/office/drawing/2014/main" id="{EBCCAB8C-E32A-4371-AEC3-D1E30CC4E5ED}"/>
+                <a16:creationId xmlns:a16="http://schemas.microsoft.com/office/drawing/2014/main" id="{AA8649D9-E68D-47D0-B119-A13F3B8F746E}"/>
               </a:ext>
             </a:extLst>
           </p:cNvPr>
@@ -7237,7 +7237,7 @@
           <p:nvPr/>
         </p:nvPicPr>
         <p:blipFill rotWithShape="1">
-          <a:blip xmlns:r="http://schemas.openxmlformats.org/officeDocument/2006/relationships" xmlns:a="http://schemas.openxmlformats.org/drawingml/2006/main" r:embed="Rd425e616ce53404b">
+          <a:blip xmlns:r="http://schemas.openxmlformats.org/officeDocument/2006/relationships" xmlns:a="http://schemas.openxmlformats.org/drawingml/2006/main" r:embed="R6b6d523be8034a91">
             <a:alphaModFix/>
           </a:blip>
           <a:srcRect xmlns:a="http://schemas.openxmlformats.org/drawingml/2006/main" l="0" t="0" r="0" b="98001"/>
@@ -7261,7 +7261,7 @@
           <p:cNvPr id="141" name="Google Shape;141;p24">
             <a:extLst xmlns:a="http://schemas.openxmlformats.org/drawingml/2006/main">
               <a:ext uri="{FF2B5EF4-FFF2-40B4-BE49-F238E27FC236}">
-                <a16:creationId xmlns:a16="http://schemas.microsoft.com/office/drawing/2014/main" id="{7A263A7D-3A16-497F-9581-9B5FDE0F532F}"/>
+                <a16:creationId xmlns:a16="http://schemas.microsoft.com/office/drawing/2014/main" id="{ADF7C7C0-D430-4AD5-8A1F-F7BEB2E3665B}"/>
               </a:ext>
             </a:extLst>
           </p:cNvPr>
@@ -7271,7 +7271,7 @@
           <p:nvPr/>
         </p:nvPicPr>
         <p:blipFill>
-          <a:blip xmlns:r="http://schemas.openxmlformats.org/officeDocument/2006/relationships" xmlns:a="http://schemas.openxmlformats.org/drawingml/2006/main" r:embed="R970f862899934de1">
+          <a:blip xmlns:r="http://schemas.openxmlformats.org/officeDocument/2006/relationships" xmlns:a="http://schemas.openxmlformats.org/drawingml/2006/main" r:embed="R52783f708b7c4af3">
             <a:alphaModFix/>
           </a:blip>
           <a:stretch xmlns:a="http://schemas.openxmlformats.org/drawingml/2006/main">
@@ -7296,7 +7296,7 @@
           <p:cNvPr id="142" name="Google Shape;142;p24">
             <a:extLst xmlns:a="http://schemas.openxmlformats.org/drawingml/2006/main">
               <a:ext uri="{FF2B5EF4-FFF2-40B4-BE49-F238E27FC236}">
-                <a16:creationId xmlns:a16="http://schemas.microsoft.com/office/drawing/2014/main" id="{E6D0B7DC-109F-4DF3-81C5-F30DEA248FAC}"/>
+                <a16:creationId xmlns:a16="http://schemas.microsoft.com/office/drawing/2014/main" id="{87EE9212-C645-4C34-A432-71391264BA3E}"/>
               </a:ext>
             </a:extLst>
           </p:cNvPr>
@@ -7347,7 +7347,7 @@
           <p:cNvPr id="143" name="Google Shape;143;p24">
             <a:extLst xmlns:a="http://schemas.openxmlformats.org/drawingml/2006/main">
               <a:ext uri="{FF2B5EF4-FFF2-40B4-BE49-F238E27FC236}">
-                <a16:creationId xmlns:a16="http://schemas.microsoft.com/office/drawing/2014/main" id="{8EA72F2C-0BE9-4201-8DF9-E4A90F1C2670}"/>
+                <a16:creationId xmlns:a16="http://schemas.microsoft.com/office/drawing/2014/main" id="{772A4140-7109-4B9B-8B32-3176DC0BB864}"/>
               </a:ext>
             </a:extLst>
           </p:cNvPr>
@@ -7427,7 +7427,7 @@
           <p:cNvPr id="144" name="">
             <a:extLst xmlns:a="http://schemas.openxmlformats.org/drawingml/2006/main">
               <a:ext uri="{FF2B5EF4-FFF2-40B4-BE49-F238E27FC236}">
-                <a16:creationId xmlns:a16="http://schemas.microsoft.com/office/drawing/2014/main" id="{16198078-FD4F-4FE5-BB1D-933B42ACE952}"/>
+                <a16:creationId xmlns:a16="http://schemas.microsoft.com/office/drawing/2014/main" id="{85A220E2-E5E4-48DF-8234-223277D28E42}"/>
               </a:ext>
             </a:extLst>
           </p:cNvPr>
@@ -7952,7 +7952,7 @@
           <p:cNvPr id="145" name="benchmark-limit">
             <a:extLst xmlns:a="http://schemas.openxmlformats.org/drawingml/2006/main">
               <a:ext uri="{FF2B5EF4-FFF2-40B4-BE49-F238E27FC236}">
-                <a16:creationId xmlns:a16="http://schemas.microsoft.com/office/drawing/2014/main" id="{9320EF53-0D55-4257-B0FA-2775DAD7C86C}"/>
+                <a16:creationId xmlns:a16="http://schemas.microsoft.com/office/drawing/2014/main" id="{095396EF-660B-42EF-82C7-958A15D14E80}"/>
               </a:ext>
             </a:extLst>
           </p:cNvPr>
@@ -8041,7 +8041,7 @@
     </p:spTree>
     <p:extLst>
       <p:ext uri="{BB962C8B-B14F-4D97-AF65-F5344CB8AC3E}">
-        <p14:creationId xmlns:p14="http://schemas.microsoft.com/office/powerpoint/2010/main" val="495827532"/>
+        <p14:creationId xmlns:p14="http://schemas.microsoft.com/office/powerpoint/2010/main" val="766688491"/>
       </p:ext>
     </p:extLst>
   </p:cSld>
@@ -8065,7 +8065,7 @@
           <p:cNvPr id="148" name="Google Shape;148;p25">
             <a:extLst xmlns:a="http://schemas.openxmlformats.org/drawingml/2006/main">
               <a:ext uri="{FF2B5EF4-FFF2-40B4-BE49-F238E27FC236}">
-                <a16:creationId xmlns:a16="http://schemas.microsoft.com/office/drawing/2014/main" id="{08277691-9EE0-450D-95A6-72F6D9581FAB}"/>
+                <a16:creationId xmlns:a16="http://schemas.microsoft.com/office/drawing/2014/main" id="{92D476CF-5DC3-4BE0-9D94-C24B51628088}"/>
               </a:ext>
             </a:extLst>
           </p:cNvPr>
@@ -8075,7 +8075,7 @@
           <p:nvPr/>
         </p:nvPicPr>
         <p:blipFill rotWithShape="1">
-          <a:blip xmlns:r="http://schemas.openxmlformats.org/officeDocument/2006/relationships" xmlns:a="http://schemas.openxmlformats.org/drawingml/2006/main" r:embed="R96d8e45632824257">
+          <a:blip xmlns:r="http://schemas.openxmlformats.org/officeDocument/2006/relationships" xmlns:a="http://schemas.openxmlformats.org/drawingml/2006/main" r:embed="R36e8f4c68ce440b3">
             <a:alphaModFix/>
           </a:blip>
           <a:srcRect xmlns:a="http://schemas.openxmlformats.org/drawingml/2006/main" l="0" t="0" r="0" b="98001"/>
@@ -8099,7 +8099,7 @@
           <p:cNvPr id="149" name="Google Shape;149;p25">
             <a:extLst xmlns:a="http://schemas.openxmlformats.org/drawingml/2006/main">
               <a:ext uri="{FF2B5EF4-FFF2-40B4-BE49-F238E27FC236}">
-                <a16:creationId xmlns:a16="http://schemas.microsoft.com/office/drawing/2014/main" id="{C5D124F5-2F4F-4EC9-B1F1-3FD78CEF6A99}"/>
+                <a16:creationId xmlns:a16="http://schemas.microsoft.com/office/drawing/2014/main" id="{D8C95ED8-85CF-4951-AE53-37203D23C23C}"/>
               </a:ext>
             </a:extLst>
           </p:cNvPr>
@@ -8109,7 +8109,7 @@
           <p:nvPr/>
         </p:nvPicPr>
         <p:blipFill>
-          <a:blip xmlns:r="http://schemas.openxmlformats.org/officeDocument/2006/relationships" xmlns:a="http://schemas.openxmlformats.org/drawingml/2006/main" r:embed="R17c14f62b89a423a">
+          <a:blip xmlns:r="http://schemas.openxmlformats.org/officeDocument/2006/relationships" xmlns:a="http://schemas.openxmlformats.org/drawingml/2006/main" r:embed="R6e56a7c830844692">
             <a:alphaModFix/>
           </a:blip>
           <a:stretch xmlns:a="http://schemas.openxmlformats.org/drawingml/2006/main">
@@ -8134,7 +8134,7 @@
           <p:cNvPr id="150" name="Google Shape;150;p25">
             <a:extLst xmlns:a="http://schemas.openxmlformats.org/drawingml/2006/main">
               <a:ext uri="{FF2B5EF4-FFF2-40B4-BE49-F238E27FC236}">
-                <a16:creationId xmlns:a16="http://schemas.microsoft.com/office/drawing/2014/main" id="{1193C18C-C7AC-45E0-B9E4-58DE9B0F9169}"/>
+                <a16:creationId xmlns:a16="http://schemas.microsoft.com/office/drawing/2014/main" id="{F4BED78F-D664-409D-8668-E66EBB6C0097}"/>
               </a:ext>
             </a:extLst>
           </p:cNvPr>
@@ -8185,7 +8185,7 @@
           <p:cNvPr id="151" name="Google Shape;151;p25">
             <a:extLst xmlns:a="http://schemas.openxmlformats.org/drawingml/2006/main">
               <a:ext uri="{FF2B5EF4-FFF2-40B4-BE49-F238E27FC236}">
-                <a16:creationId xmlns:a16="http://schemas.microsoft.com/office/drawing/2014/main" id="{0A1EE611-5BE7-4C1A-AFE3-7AF9AF827276}"/>
+                <a16:creationId xmlns:a16="http://schemas.microsoft.com/office/drawing/2014/main" id="{EABE2B91-CCDF-4E73-A1D4-A5485C9D9FD7}"/>
               </a:ext>
             </a:extLst>
           </p:cNvPr>
@@ -8265,7 +8265,7 @@
           <p:cNvPr id="152" name="future-heading-0">
             <a:extLst xmlns:a="http://schemas.openxmlformats.org/drawingml/2006/main">
               <a:ext uri="{FF2B5EF4-FFF2-40B4-BE49-F238E27FC236}">
-                <a16:creationId xmlns:a16="http://schemas.microsoft.com/office/drawing/2014/main" id="{F6B26624-68FB-408A-864E-7EDE48F69F63}"/>
+                <a16:creationId xmlns:a16="http://schemas.microsoft.com/office/drawing/2014/main" id="{F85B830E-37DA-4A29-A2E0-818AD3D57B19}"/>
               </a:ext>
             </a:extLst>
           </p:cNvPr>
@@ -8333,7 +8333,7 @@
           <p:cNvPr id="153" name="future-body-0">
             <a:extLst xmlns:a="http://schemas.openxmlformats.org/drawingml/2006/main">
               <a:ext uri="{FF2B5EF4-FFF2-40B4-BE49-F238E27FC236}">
-                <a16:creationId xmlns:a16="http://schemas.microsoft.com/office/drawing/2014/main" id="{CC52B567-22E6-446C-A981-52B68FA4FF22}"/>
+                <a16:creationId xmlns:a16="http://schemas.microsoft.com/office/drawing/2014/main" id="{4947EC7F-14B7-4E89-A54E-443270A0A8A8}"/>
               </a:ext>
             </a:extLst>
           </p:cNvPr>
@@ -8414,7 +8414,7 @@
                 <a:ea typeface="Google Sans Flex"/>
                 <a:cs typeface="Google Sans Flex"/>
               </a:rPr>
-              <a:t>One lab instance, ephemeral evidence and a shared approval credential.</a:t>
+              <a:t>One lab instance, ephemeral evidence and open demo approval.</a:t>
             </a:r>
           </a:p>
         </p:txBody>
@@ -8424,7 +8424,7 @@
           <p:cNvPr id="154" name="future-heading-1">
             <a:extLst xmlns:a="http://schemas.openxmlformats.org/drawingml/2006/main">
               <a:ext uri="{FF2B5EF4-FFF2-40B4-BE49-F238E27FC236}">
-                <a16:creationId xmlns:a16="http://schemas.microsoft.com/office/drawing/2014/main" id="{45B42898-CB64-457B-B4A1-A809ADB64830}"/>
+                <a16:creationId xmlns:a16="http://schemas.microsoft.com/office/drawing/2014/main" id="{8A5AF988-ED9B-4247-95CA-0D27A4AF7106}"/>
               </a:ext>
             </a:extLst>
           </p:cNvPr>
@@ -8492,7 +8492,7 @@
           <p:cNvPr id="155" name="future-body-1">
             <a:extLst xmlns:a="http://schemas.openxmlformats.org/drawingml/2006/main">
               <a:ext uri="{FF2B5EF4-FFF2-40B4-BE49-F238E27FC236}">
-                <a16:creationId xmlns:a16="http://schemas.microsoft.com/office/drawing/2014/main" id="{FA971F3D-38CC-4CB1-9936-C58451F90070}"/>
+                <a16:creationId xmlns:a16="http://schemas.microsoft.com/office/drawing/2014/main" id="{C7B16CF7-9D98-448D-81DF-00667A958413}"/>
               </a:ext>
             </a:extLst>
           </p:cNvPr>
@@ -8583,7 +8583,7 @@
           <p:cNvPr id="156" name="future-heading-2">
             <a:extLst xmlns:a="http://schemas.openxmlformats.org/drawingml/2006/main">
               <a:ext uri="{FF2B5EF4-FFF2-40B4-BE49-F238E27FC236}">
-                <a16:creationId xmlns:a16="http://schemas.microsoft.com/office/drawing/2014/main" id="{EB9F3668-853A-4A0A-9DE2-33BE539E9996}"/>
+                <a16:creationId xmlns:a16="http://schemas.microsoft.com/office/drawing/2014/main" id="{1F4E4466-B69E-4CE5-83A2-6B311B77D058}"/>
               </a:ext>
             </a:extLst>
           </p:cNvPr>
@@ -8651,7 +8651,7 @@
           <p:cNvPr id="157" name="future-body-2">
             <a:extLst xmlns:a="http://schemas.openxmlformats.org/drawingml/2006/main">
               <a:ext uri="{FF2B5EF4-FFF2-40B4-BE49-F238E27FC236}">
-                <a16:creationId xmlns:a16="http://schemas.microsoft.com/office/drawing/2014/main" id="{4A7DF1C3-3E6D-413B-BE47-27D44FAD0B8F}"/>
+                <a16:creationId xmlns:a16="http://schemas.microsoft.com/office/drawing/2014/main" id="{BAF3FB6E-D24B-4914-9649-A446AF160573}"/>
               </a:ext>
             </a:extLst>
           </p:cNvPr>
@@ -8742,7 +8742,7 @@
           <p:cNvPr id="158" name="future-heading-3">
             <a:extLst xmlns:a="http://schemas.openxmlformats.org/drawingml/2006/main">
               <a:ext uri="{FF2B5EF4-FFF2-40B4-BE49-F238E27FC236}">
-                <a16:creationId xmlns:a16="http://schemas.microsoft.com/office/drawing/2014/main" id="{A4E95562-79B3-4C40-BAB4-1248C91BB759}"/>
+                <a16:creationId xmlns:a16="http://schemas.microsoft.com/office/drawing/2014/main" id="{3809037F-8980-43CF-8ECD-3F6E05701792}"/>
               </a:ext>
             </a:extLst>
           </p:cNvPr>
@@ -8810,7 +8810,7 @@
           <p:cNvPr id="159" name="future-body-3">
             <a:extLst xmlns:a="http://schemas.openxmlformats.org/drawingml/2006/main">
               <a:ext uri="{FF2B5EF4-FFF2-40B4-BE49-F238E27FC236}">
-                <a16:creationId xmlns:a16="http://schemas.microsoft.com/office/drawing/2014/main" id="{52025D76-AB4B-44D2-AA47-27B8D18E9C46}"/>
+                <a16:creationId xmlns:a16="http://schemas.microsoft.com/office/drawing/2014/main" id="{FD17B808-71EA-4140-8E28-FC5EBB89556C}"/>
               </a:ext>
             </a:extLst>
           </p:cNvPr>
@@ -8899,7 +8899,7 @@
     </p:spTree>
     <p:extLst>
       <p:ext uri="{BB962C8B-B14F-4D97-AF65-F5344CB8AC3E}">
-        <p14:creationId xmlns:p14="http://schemas.microsoft.com/office/powerpoint/2010/main" val="169488302"/>
+        <p14:creationId xmlns:p14="http://schemas.microsoft.com/office/powerpoint/2010/main" val="2018056352"/>
       </p:ext>
     </p:extLst>
   </p:cSld>
@@ -8923,7 +8923,7 @@
           <p:cNvPr id="156" name="Google Shape;156;p26">
             <a:extLst xmlns:a="http://schemas.openxmlformats.org/drawingml/2006/main">
               <a:ext uri="{FF2B5EF4-FFF2-40B4-BE49-F238E27FC236}">
-                <a16:creationId xmlns:a16="http://schemas.microsoft.com/office/drawing/2014/main" id="{CCC2C057-415D-42C2-BEAB-B1532D81B0D2}"/>
+                <a16:creationId xmlns:a16="http://schemas.microsoft.com/office/drawing/2014/main" id="{5C5B1800-C05C-425D-ADE2-8CD09BCCE198}"/>
               </a:ext>
             </a:extLst>
           </p:cNvPr>
@@ -8933,7 +8933,7 @@
           <p:nvPr/>
         </p:nvPicPr>
         <p:blipFill rotWithShape="1">
-          <a:blip xmlns:r="http://schemas.openxmlformats.org/officeDocument/2006/relationships" xmlns:a="http://schemas.openxmlformats.org/drawingml/2006/main" r:embed="R05854d012ba4461f">
+          <a:blip xmlns:r="http://schemas.openxmlformats.org/officeDocument/2006/relationships" xmlns:a="http://schemas.openxmlformats.org/drawingml/2006/main" r:embed="Rf61de4273ad842f4">
             <a:alphaModFix/>
           </a:blip>
           <a:srcRect xmlns:a="http://schemas.openxmlformats.org/drawingml/2006/main" l="0" t="0" r="0" b="98001"/>
@@ -8957,7 +8957,7 @@
           <p:cNvPr id="157" name="Google Shape;157;p26">
             <a:extLst xmlns:a="http://schemas.openxmlformats.org/drawingml/2006/main">
               <a:ext uri="{FF2B5EF4-FFF2-40B4-BE49-F238E27FC236}">
-                <a16:creationId xmlns:a16="http://schemas.microsoft.com/office/drawing/2014/main" id="{FA678E1E-220B-4D82-986B-72E34A1FFDCC}"/>
+                <a16:creationId xmlns:a16="http://schemas.microsoft.com/office/drawing/2014/main" id="{2EA7E9E5-1DFC-4B44-BCED-08FC3BA384EC}"/>
               </a:ext>
             </a:extLst>
           </p:cNvPr>
@@ -8967,7 +8967,7 @@
           <p:nvPr/>
         </p:nvPicPr>
         <p:blipFill>
-          <a:blip xmlns:r="http://schemas.openxmlformats.org/officeDocument/2006/relationships" xmlns:a="http://schemas.openxmlformats.org/drawingml/2006/main" r:embed="R9964ebd679b548c6">
+          <a:blip xmlns:r="http://schemas.openxmlformats.org/officeDocument/2006/relationships" xmlns:a="http://schemas.openxmlformats.org/drawingml/2006/main" r:embed="Rc6f1a457ba164437">
             <a:alphaModFix/>
           </a:blip>
           <a:stretch xmlns:a="http://schemas.openxmlformats.org/drawingml/2006/main">
@@ -8992,7 +8992,7 @@
           <p:cNvPr id="158" name="Google Shape;158;p26">
             <a:extLst xmlns:a="http://schemas.openxmlformats.org/drawingml/2006/main">
               <a:ext uri="{FF2B5EF4-FFF2-40B4-BE49-F238E27FC236}">
-                <a16:creationId xmlns:a16="http://schemas.microsoft.com/office/drawing/2014/main" id="{25AFBF04-13F2-4C08-80D0-133DBA48FB8D}"/>
+                <a16:creationId xmlns:a16="http://schemas.microsoft.com/office/drawing/2014/main" id="{D96469FE-FFAC-41E5-BFA0-4F119929F83C}"/>
               </a:ext>
             </a:extLst>
           </p:cNvPr>
@@ -9043,7 +9043,7 @@
           <p:cNvPr id="159" name="Google Shape;159;p26">
             <a:extLst xmlns:a="http://schemas.openxmlformats.org/drawingml/2006/main">
               <a:ext uri="{FF2B5EF4-FFF2-40B4-BE49-F238E27FC236}">
-                <a16:creationId xmlns:a16="http://schemas.microsoft.com/office/drawing/2014/main" id="{935ECD52-E7A3-4C64-83D0-936EE39AC063}"/>
+                <a16:creationId xmlns:a16="http://schemas.microsoft.com/office/drawing/2014/main" id="{0E6B943E-BC24-4EF9-83DD-CF25F83DB519}"/>
               </a:ext>
             </a:extLst>
           </p:cNvPr>
@@ -9123,7 +9123,7 @@
           <p:cNvPr id="160" name="GitHub public repository label">
             <a:extLst xmlns:a="http://schemas.openxmlformats.org/drawingml/2006/main">
               <a:ext uri="{FF2B5EF4-FFF2-40B4-BE49-F238E27FC236}">
-                <a16:creationId xmlns:a16="http://schemas.microsoft.com/office/drawing/2014/main" id="{EA2810B5-7E02-4446-AF30-D9EEE8B5F50B}"/>
+                <a16:creationId xmlns:a16="http://schemas.microsoft.com/office/drawing/2014/main" id="{3D95692B-CAF3-4C90-A562-24D89FFEDAA7}"/>
               </a:ext>
             </a:extLst>
           </p:cNvPr>
@@ -9191,7 +9191,7 @@
           <p:cNvPr id="161" name="GitHub public repository URL">
             <a:extLst xmlns:a="http://schemas.openxmlformats.org/drawingml/2006/main">
               <a:ext uri="{FF2B5EF4-FFF2-40B4-BE49-F238E27FC236}">
-                <a16:creationId xmlns:a16="http://schemas.microsoft.com/office/drawing/2014/main" id="{EA64D02E-11E0-40EF-95AC-6371454F4D3D}"/>
+                <a16:creationId xmlns:a16="http://schemas.microsoft.com/office/drawing/2014/main" id="{9E5DFBD3-DBC6-45E3-ABBA-31CC9D244764}"/>
               </a:ext>
             </a:extLst>
           </p:cNvPr>
@@ -9248,7 +9248,7 @@
                 <a:latin typeface="Google Sans Flex"/>
                 <a:ea typeface="Google Sans Flex"/>
                 <a:cs typeface="Google Sans Flex"/>
-                <a:hlinkClick xmlns:r="http://schemas.openxmlformats.org/officeDocument/2006/relationships" r:id="Rd6049b4cc6304a15"/>
+                <a:hlinkClick xmlns:r="http://schemas.openxmlformats.org/officeDocument/2006/relationships" r:id="R5b148af9622a4a9c"/>
               </a:rPr>
               <a:t>https://github.com/prabhakarcs786/twinops</a:t>
             </a:r>
@@ -9260,7 +9260,7 @@
           <p:cNvPr id="162" name="Demo video label">
             <a:extLst xmlns:a="http://schemas.openxmlformats.org/drawingml/2006/main">
               <a:ext uri="{FF2B5EF4-FFF2-40B4-BE49-F238E27FC236}">
-                <a16:creationId xmlns:a16="http://schemas.microsoft.com/office/drawing/2014/main" id="{DB7BF42A-876D-4BBA-97AF-968CBD0E02D2}"/>
+                <a16:creationId xmlns:a16="http://schemas.microsoft.com/office/drawing/2014/main" id="{AFD84E50-8C28-480A-A722-31A68324F83F}"/>
               </a:ext>
             </a:extLst>
           </p:cNvPr>
@@ -9328,7 +9328,7 @@
           <p:cNvPr id="163" name="Demo video URL">
             <a:extLst xmlns:a="http://schemas.openxmlformats.org/drawingml/2006/main">
               <a:ext uri="{FF2B5EF4-FFF2-40B4-BE49-F238E27FC236}">
-                <a16:creationId xmlns:a16="http://schemas.microsoft.com/office/drawing/2014/main" id="{F80E34D9-EAA9-4FF8-A37F-223B01B833D7}"/>
+                <a16:creationId xmlns:a16="http://schemas.microsoft.com/office/drawing/2014/main" id="{DAB311BE-5D7E-46A3-AB26-F36BB8377B0B}"/>
               </a:ext>
             </a:extLst>
           </p:cNvPr>
@@ -9385,7 +9385,7 @@
                 <a:latin typeface="Google Sans Flex"/>
                 <a:ea typeface="Google Sans Flex"/>
                 <a:cs typeface="Google Sans Flex"/>
-                <a:hlinkClick xmlns:r="http://schemas.openxmlformats.org/officeDocument/2006/relationships" r:id="R990a349f3828444f"/>
+                <a:hlinkClick xmlns:r="http://schemas.openxmlformats.org/officeDocument/2006/relationships" r:id="R3832fb2a23b6453b"/>
               </a:rPr>
               <a:t>https://youtu.be/0LjDHiUBy0Y</a:t>
             </a:r>
@@ -9397,7 +9397,7 @@
           <p:cNvPr id="164" name="Final product: TwinOps workbench label">
             <a:extLst xmlns:a="http://schemas.openxmlformats.org/drawingml/2006/main">
               <a:ext uri="{FF2B5EF4-FFF2-40B4-BE49-F238E27FC236}">
-                <a16:creationId xmlns:a16="http://schemas.microsoft.com/office/drawing/2014/main" id="{F4C456D9-32B4-4EF7-BFA1-D6E14E2AEDE7}"/>
+                <a16:creationId xmlns:a16="http://schemas.microsoft.com/office/drawing/2014/main" id="{41A486B5-EF3F-4410-8A07-869696236908}"/>
               </a:ext>
             </a:extLst>
           </p:cNvPr>
@@ -9465,7 +9465,7 @@
           <p:cNvPr id="165" name="Final product: TwinOps workbench URL">
             <a:extLst xmlns:a="http://schemas.openxmlformats.org/drawingml/2006/main">
               <a:ext uri="{FF2B5EF4-FFF2-40B4-BE49-F238E27FC236}">
-                <a16:creationId xmlns:a16="http://schemas.microsoft.com/office/drawing/2014/main" id="{24333C1B-66DA-4E6D-9F99-EBE189EDDCFE}"/>
+                <a16:creationId xmlns:a16="http://schemas.microsoft.com/office/drawing/2014/main" id="{A7BEFA48-196E-44C8-BC6F-588C6C7F5729}"/>
               </a:ext>
             </a:extLst>
           </p:cNvPr>
@@ -9522,7 +9522,7 @@
                 <a:latin typeface="Google Sans Flex"/>
                 <a:ea typeface="Google Sans Flex"/>
                 <a:cs typeface="Google Sans Flex"/>
-                <a:hlinkClick xmlns:r="http://schemas.openxmlformats.org/officeDocument/2006/relationships" r:id="R10b4bd3dbc824b2a"/>
+                <a:hlinkClick xmlns:r="http://schemas.openxmlformats.org/officeDocument/2006/relationships" r:id="R7359fce136114f9c"/>
               </a:rPr>
               <a:t>https://twinops-live-705406130795.europe-west1.run.app/workbench</a:t>
             </a:r>
@@ -9534,7 +9534,7 @@
           <p:cNvPr id="166" name="Connected application: Metro Network label">
             <a:extLst xmlns:a="http://schemas.openxmlformats.org/drawingml/2006/main">
               <a:ext uri="{FF2B5EF4-FFF2-40B4-BE49-F238E27FC236}">
-                <a16:creationId xmlns:a16="http://schemas.microsoft.com/office/drawing/2014/main" id="{DD06E0AB-068F-4980-BC3B-7F7FCD0D44D0}"/>
+                <a16:creationId xmlns:a16="http://schemas.microsoft.com/office/drawing/2014/main" id="{34251418-71B1-42E8-AA37-8B5769CA7ABC}"/>
               </a:ext>
             </a:extLst>
           </p:cNvPr>
@@ -9602,7 +9602,7 @@
           <p:cNvPr id="167" name="Connected application: Metro Network URL">
             <a:extLst xmlns:a="http://schemas.openxmlformats.org/drawingml/2006/main">
               <a:ext uri="{FF2B5EF4-FFF2-40B4-BE49-F238E27FC236}">
-                <a16:creationId xmlns:a16="http://schemas.microsoft.com/office/drawing/2014/main" id="{3D293376-90DF-464C-AFDC-7D0DF120644B}"/>
+                <a16:creationId xmlns:a16="http://schemas.microsoft.com/office/drawing/2014/main" id="{5C83399C-E712-4092-838D-486878CDFF08}"/>
               </a:ext>
             </a:extLst>
           </p:cNvPr>
@@ -9659,7 +9659,7 @@
                 <a:latin typeface="Google Sans Flex"/>
                 <a:ea typeface="Google Sans Flex"/>
                 <a:cs typeface="Google Sans Flex"/>
-                <a:hlinkClick xmlns:r="http://schemas.openxmlformats.org/officeDocument/2006/relationships" r:id="Rbb4eba4bc19b4c98"/>
+                <a:hlinkClick xmlns:r="http://schemas.openxmlformats.org/officeDocument/2006/relationships" r:id="R00ccc5e853b74927"/>
               </a:rPr>
               <a:t>https://twinops-live-705406130795.europe-west1.run.app/metro/</a:t>
             </a:r>
@@ -9671,7 +9671,7 @@
           <p:cNvPr id="168" name="judge-guide">
             <a:extLst xmlns:a="http://schemas.openxmlformats.org/drawingml/2006/main">
               <a:ext uri="{FF2B5EF4-FFF2-40B4-BE49-F238E27FC236}">
-                <a16:creationId xmlns:a16="http://schemas.microsoft.com/office/drawing/2014/main" id="{862C05BA-66E2-4204-ADE9-3C786662D78F}"/>
+                <a16:creationId xmlns:a16="http://schemas.microsoft.com/office/drawing/2014/main" id="{0D1C66DA-7973-417C-8E3F-96FB1AB5E731}"/>
               </a:ext>
             </a:extLst>
           </p:cNvPr>
@@ -9728,7 +9728,7 @@
                 <a:latin typeface="Google Sans Flex"/>
                 <a:ea typeface="Google Sans Flex"/>
                 <a:cs typeface="Google Sans Flex"/>
-                <a:hlinkClick xmlns:r="http://schemas.openxmlformats.org/officeDocument/2006/relationships" r:id="R80a21f21ddbe4bdc"/>
+                <a:hlinkClick xmlns:r="http://schemas.openxmlformats.org/officeDocument/2006/relationships" r:id="Rf6374183e0be4888"/>
               </a:rPr>
               <a:t>Review access and walkthrough: GitHub / docs / JUDGE_GUIDE.md</a:t>
             </a:r>
@@ -9738,7 +9738,7 @@
     </p:spTree>
     <p:extLst>
       <p:ext uri="{BB962C8B-B14F-4D97-AF65-F5344CB8AC3E}">
-        <p14:creationId xmlns:p14="http://schemas.microsoft.com/office/powerpoint/2010/main" val="120098593"/>
+        <p14:creationId xmlns:p14="http://schemas.microsoft.com/office/powerpoint/2010/main" val="1959696961"/>
       </p:ext>
     </p:extLst>
   </p:cSld>
@@ -9762,7 +9762,7 @@
           <p:cNvPr id="171" name="Google Shape;171;p28">
             <a:extLst xmlns:a="http://schemas.openxmlformats.org/drawingml/2006/main">
               <a:ext uri="{FF2B5EF4-FFF2-40B4-BE49-F238E27FC236}">
-                <a16:creationId xmlns:a16="http://schemas.microsoft.com/office/drawing/2014/main" id="{058C9D23-1987-4C68-8067-15567578482A}"/>
+                <a16:creationId xmlns:a16="http://schemas.microsoft.com/office/drawing/2014/main" id="{CCD43FDD-FB42-4E24-9CB1-E82A66497CFF}"/>
               </a:ext>
             </a:extLst>
           </p:cNvPr>
@@ -9772,7 +9772,7 @@
           <p:nvPr/>
         </p:nvPicPr>
         <p:blipFill rotWithShape="1">
-          <a:blip xmlns:r="http://schemas.openxmlformats.org/officeDocument/2006/relationships" xmlns:a="http://schemas.openxmlformats.org/drawingml/2006/main" r:embed="Re56bd39a764449fe">
+          <a:blip xmlns:r="http://schemas.openxmlformats.org/officeDocument/2006/relationships" xmlns:a="http://schemas.openxmlformats.org/drawingml/2006/main" r:embed="Rb769fc645d9948ef">
             <a:alphaModFix/>
           </a:blip>
           <a:srcRect xmlns:a="http://schemas.openxmlformats.org/drawingml/2006/main" l="0" t="0" r="0" b="98001"/>
@@ -9796,7 +9796,7 @@
           <p:cNvPr id="172" name="Google Shape;172;p28">
             <a:extLst xmlns:a="http://schemas.openxmlformats.org/drawingml/2006/main">
               <a:ext uri="{FF2B5EF4-FFF2-40B4-BE49-F238E27FC236}">
-                <a16:creationId xmlns:a16="http://schemas.microsoft.com/office/drawing/2014/main" id="{33B0EB3B-1D8F-4842-8096-12DCDAB1DC11}"/>
+                <a16:creationId xmlns:a16="http://schemas.microsoft.com/office/drawing/2014/main" id="{E11810C0-0B1C-456B-ACB0-5218B4D4391D}"/>
               </a:ext>
             </a:extLst>
           </p:cNvPr>
@@ -9806,7 +9806,7 @@
           <p:nvPr/>
         </p:nvPicPr>
         <p:blipFill>
-          <a:blip xmlns:r="http://schemas.openxmlformats.org/officeDocument/2006/relationships" xmlns:a="http://schemas.openxmlformats.org/drawingml/2006/main" r:embed="R7017c2dc29264fd3">
+          <a:blip xmlns:r="http://schemas.openxmlformats.org/officeDocument/2006/relationships" xmlns:a="http://schemas.openxmlformats.org/drawingml/2006/main" r:embed="Rc124d27169e048ab">
             <a:alphaModFix/>
           </a:blip>
           <a:stretch xmlns:a="http://schemas.openxmlformats.org/drawingml/2006/main">
@@ -9829,7 +9829,7 @@
     </p:spTree>
     <p:extLst>
       <p:ext uri="{BB962C8B-B14F-4D97-AF65-F5344CB8AC3E}">
-        <p14:creationId xmlns:p14="http://schemas.microsoft.com/office/powerpoint/2010/main" val="77885400"/>
+        <p14:creationId xmlns:p14="http://schemas.microsoft.com/office/powerpoint/2010/main" val="110863680"/>
       </p:ext>
     </p:extLst>
   </p:cSld>
@@ -9853,7 +9853,7 @@
           <p:cNvPr id="69" name="Google Shape;69;p15">
             <a:extLst xmlns:a="http://schemas.openxmlformats.org/drawingml/2006/main">
               <a:ext uri="{FF2B5EF4-FFF2-40B4-BE49-F238E27FC236}">
-                <a16:creationId xmlns:a16="http://schemas.microsoft.com/office/drawing/2014/main" id="{D1A9192A-D2E4-4725-BB39-1DFC4A88ED18}"/>
+                <a16:creationId xmlns:a16="http://schemas.microsoft.com/office/drawing/2014/main" id="{BE00F0CB-6A8A-40D1-8CFD-7A24AB396855}"/>
               </a:ext>
             </a:extLst>
           </p:cNvPr>
@@ -9863,7 +9863,7 @@
           <p:nvPr/>
         </p:nvPicPr>
         <p:blipFill>
-          <a:blip xmlns:r="http://schemas.openxmlformats.org/officeDocument/2006/relationships" xmlns:a="http://schemas.openxmlformats.org/drawingml/2006/main" r:embed="R966fc945f1394fcb">
+          <a:blip xmlns:r="http://schemas.openxmlformats.org/officeDocument/2006/relationships" xmlns:a="http://schemas.openxmlformats.org/drawingml/2006/main" r:embed="R3a9bd06b2c344346">
             <a:alphaModFix/>
           </a:blip>
           <a:stretch xmlns:a="http://schemas.openxmlformats.org/drawingml/2006/main">
@@ -9888,7 +9888,7 @@
           <p:cNvPr id="70" name="Google Shape;70;p15">
             <a:extLst xmlns:a="http://schemas.openxmlformats.org/drawingml/2006/main">
               <a:ext uri="{FF2B5EF4-FFF2-40B4-BE49-F238E27FC236}">
-                <a16:creationId xmlns:a16="http://schemas.microsoft.com/office/drawing/2014/main" id="{09B93712-1DF9-4DB1-AD6D-74D5E6270F64}"/>
+                <a16:creationId xmlns:a16="http://schemas.microsoft.com/office/drawing/2014/main" id="{4B0A8290-D3AB-4F8D-BACA-7F98BE98F2DB}"/>
               </a:ext>
             </a:extLst>
           </p:cNvPr>
@@ -9939,7 +9939,7 @@
           <p:cNvPr id="71" name="Google Shape;71;p15">
             <a:extLst xmlns:a="http://schemas.openxmlformats.org/drawingml/2006/main">
               <a:ext uri="{FF2B5EF4-FFF2-40B4-BE49-F238E27FC236}">
-                <a16:creationId xmlns:a16="http://schemas.microsoft.com/office/drawing/2014/main" id="{A0575BEB-7F23-484C-8AF3-93E475216F13}"/>
+                <a16:creationId xmlns:a16="http://schemas.microsoft.com/office/drawing/2014/main" id="{8D50581E-79FD-43E3-8BB2-DBF564FEB512}"/>
               </a:ext>
             </a:extLst>
           </p:cNvPr>
@@ -10019,7 +10019,7 @@
           <p:cNvPr id="72" name="idea-headline">
             <a:extLst xmlns:a="http://schemas.openxmlformats.org/drawingml/2006/main">
               <a:ext uri="{FF2B5EF4-FFF2-40B4-BE49-F238E27FC236}">
-                <a16:creationId xmlns:a16="http://schemas.microsoft.com/office/drawing/2014/main" id="{8DC6DAC6-E7E4-42B1-9251-E331D279D9E3}"/>
+                <a16:creationId xmlns:a16="http://schemas.microsoft.com/office/drawing/2014/main" id="{F64DD29C-2152-41CA-AC50-34443A9AF97B}"/>
               </a:ext>
             </a:extLst>
           </p:cNvPr>
@@ -10087,7 +10087,7 @@
           <p:cNvPr id="73" name="">
             <a:extLst xmlns:a="http://schemas.openxmlformats.org/drawingml/2006/main">
               <a:ext uri="{FF2B5EF4-FFF2-40B4-BE49-F238E27FC236}">
-                <a16:creationId xmlns:a16="http://schemas.microsoft.com/office/drawing/2014/main" id="{59657331-B6AD-4D16-8A68-C8C37542DBA4}"/>
+                <a16:creationId xmlns:a16="http://schemas.microsoft.com/office/drawing/2014/main" id="{86252ADB-4AFD-4F72-B90A-A1A059164004}"/>
               </a:ext>
             </a:extLst>
           </p:cNvPr>
@@ -10097,7 +10097,7 @@
           <p:nvPr/>
         </p:nvPicPr>
         <p:blipFill>
-          <a:blip xmlns:r="http://schemas.openxmlformats.org/officeDocument/2006/relationships" xmlns:a="http://schemas.openxmlformats.org/drawingml/2006/main" r:embed="Rda4bcb8bf7c740b6"/>
+          <a:blip xmlns:r="http://schemas.openxmlformats.org/officeDocument/2006/relationships" xmlns:a="http://schemas.openxmlformats.org/drawingml/2006/main" r:embed="R67e5f51653794e83"/>
           <a:srcRect xmlns:a="http://schemas.openxmlformats.org/drawingml/2006/main" l="19500" t="26700" r="47000" b="33700"/>
           <a:stretch xmlns:a="http://schemas.openxmlformats.org/drawingml/2006/main"/>
         </p:blipFill>
@@ -10116,7 +10116,7 @@
           <p:cNvPr id="74" name="problem">
             <a:extLst xmlns:a="http://schemas.openxmlformats.org/drawingml/2006/main">
               <a:ext uri="{FF2B5EF4-FFF2-40B4-BE49-F238E27FC236}">
-                <a16:creationId xmlns:a16="http://schemas.microsoft.com/office/drawing/2014/main" id="{E393671F-1FBB-482D-95DC-4A34E4239D48}"/>
+                <a16:creationId xmlns:a16="http://schemas.microsoft.com/office/drawing/2014/main" id="{6DA720C1-A06C-4F7D-97B1-C2991941D32F}"/>
               </a:ext>
             </a:extLst>
           </p:cNvPr>
@@ -10184,7 +10184,7 @@
           <p:cNvPr id="75" name="problem-body">
             <a:extLst xmlns:a="http://schemas.openxmlformats.org/drawingml/2006/main">
               <a:ext uri="{FF2B5EF4-FFF2-40B4-BE49-F238E27FC236}">
-                <a16:creationId xmlns:a16="http://schemas.microsoft.com/office/drawing/2014/main" id="{C1D8F9E1-FF35-43E1-A962-F46D6290DBA7}"/>
+                <a16:creationId xmlns:a16="http://schemas.microsoft.com/office/drawing/2014/main" id="{2187E528-0AB9-4D80-81EC-AC8CB15EAB0D}"/>
               </a:ext>
             </a:extLst>
           </p:cNvPr>
@@ -10275,7 +10275,7 @@
           <p:cNvPr id="76" name="solution">
             <a:extLst xmlns:a="http://schemas.openxmlformats.org/drawingml/2006/main">
               <a:ext uri="{FF2B5EF4-FFF2-40B4-BE49-F238E27FC236}">
-                <a16:creationId xmlns:a16="http://schemas.microsoft.com/office/drawing/2014/main" id="{BDD38F00-59EB-429B-9315-C6561DF45695}"/>
+                <a16:creationId xmlns:a16="http://schemas.microsoft.com/office/drawing/2014/main" id="{0BCAEBF3-3545-4566-B7A4-BABB204E08FC}"/>
               </a:ext>
             </a:extLst>
           </p:cNvPr>
@@ -10343,7 +10343,7 @@
           <p:cNvPr id="77" name="solution-body">
             <a:extLst xmlns:a="http://schemas.openxmlformats.org/drawingml/2006/main">
               <a:ext uri="{FF2B5EF4-FFF2-40B4-BE49-F238E27FC236}">
-                <a16:creationId xmlns:a16="http://schemas.microsoft.com/office/drawing/2014/main" id="{803FDCEC-C7C1-4448-921F-9CCE72EA214F}"/>
+                <a16:creationId xmlns:a16="http://schemas.microsoft.com/office/drawing/2014/main" id="{7385F865-9993-4113-887A-93B1AAC43E16}"/>
               </a:ext>
             </a:extLst>
           </p:cNvPr>
@@ -10480,7 +10480,7 @@
           <p:cNvPr id="78" name="definition">
             <a:extLst xmlns:a="http://schemas.openxmlformats.org/drawingml/2006/main">
               <a:ext uri="{FF2B5EF4-FFF2-40B4-BE49-F238E27FC236}">
-                <a16:creationId xmlns:a16="http://schemas.microsoft.com/office/drawing/2014/main" id="{62E80767-04AB-4146-872F-3B237C43303F}"/>
+                <a16:creationId xmlns:a16="http://schemas.microsoft.com/office/drawing/2014/main" id="{779DB2C7-0A48-4264-8CCB-909D00CD3451}"/>
               </a:ext>
             </a:extLst>
           </p:cNvPr>
@@ -10546,7 +10546,7 @@
     </p:spTree>
     <p:extLst>
       <p:ext uri="{BB962C8B-B14F-4D97-AF65-F5344CB8AC3E}">
-        <p14:creationId xmlns:p14="http://schemas.microsoft.com/office/powerpoint/2010/main" val="1616949722"/>
+        <p14:creationId xmlns:p14="http://schemas.microsoft.com/office/powerpoint/2010/main" val="1697966928"/>
       </p:ext>
     </p:extLst>
   </p:cSld>
@@ -10570,7 +10570,7 @@
           <p:cNvPr id="87" name="">
             <a:extLst xmlns:a="http://schemas.openxmlformats.org/drawingml/2006/main">
               <a:ext uri="{FF2B5EF4-FFF2-40B4-BE49-F238E27FC236}">
-                <a16:creationId xmlns:a16="http://schemas.microsoft.com/office/drawing/2014/main" id="{7A01BBD3-E30A-42F3-A4CA-5804E88E2FB1}"/>
+                <a16:creationId xmlns:a16="http://schemas.microsoft.com/office/drawing/2014/main" id="{89EBCA55-FCF6-47A3-A9B4-149A46BAC4EC}"/>
               </a:ext>
             </a:extLst>
           </p:cNvPr>
@@ -10601,7 +10601,7 @@
           <p:cNvPr id="86" name="">
             <a:extLst xmlns:a="http://schemas.openxmlformats.org/drawingml/2006/main">
               <a:ext uri="{FF2B5EF4-FFF2-40B4-BE49-F238E27FC236}">
-                <a16:creationId xmlns:a16="http://schemas.microsoft.com/office/drawing/2014/main" id="{088EA86F-646D-455A-9A63-184D163796BC}"/>
+                <a16:creationId xmlns:a16="http://schemas.microsoft.com/office/drawing/2014/main" id="{5ACF782B-4CF8-4B9F-9BAB-280FE77CCD69}"/>
               </a:ext>
             </a:extLst>
           </p:cNvPr>
@@ -10632,7 +10632,7 @@
           <p:cNvPr id="85" name="">
             <a:extLst xmlns:a="http://schemas.openxmlformats.org/drawingml/2006/main">
               <a:ext uri="{FF2B5EF4-FFF2-40B4-BE49-F238E27FC236}">
-                <a16:creationId xmlns:a16="http://schemas.microsoft.com/office/drawing/2014/main" id="{894B8E4F-EF3E-41FE-874A-46840469094F}"/>
+                <a16:creationId xmlns:a16="http://schemas.microsoft.com/office/drawing/2014/main" id="{B6E52292-5767-4EB9-A3F4-51AB2EA76F49}"/>
               </a:ext>
             </a:extLst>
           </p:cNvPr>
@@ -10663,7 +10663,7 @@
           <p:cNvPr id="76" name="Google Shape;76;p16">
             <a:extLst xmlns:a="http://schemas.openxmlformats.org/drawingml/2006/main">
               <a:ext uri="{FF2B5EF4-FFF2-40B4-BE49-F238E27FC236}">
-                <a16:creationId xmlns:a16="http://schemas.microsoft.com/office/drawing/2014/main" id="{DCDD9596-E450-4C70-85EF-AD963CC9AE9E}"/>
+                <a16:creationId xmlns:a16="http://schemas.microsoft.com/office/drawing/2014/main" id="{BE9A252B-F358-490F-B22A-19F40247D329}"/>
               </a:ext>
             </a:extLst>
           </p:cNvPr>
@@ -10673,7 +10673,7 @@
           <p:nvPr/>
         </p:nvPicPr>
         <p:blipFill rotWithShape="1">
-          <a:blip xmlns:r="http://schemas.openxmlformats.org/officeDocument/2006/relationships" xmlns:a="http://schemas.openxmlformats.org/drawingml/2006/main" r:embed="R8da834dcf66340fc">
+          <a:blip xmlns:r="http://schemas.openxmlformats.org/officeDocument/2006/relationships" xmlns:a="http://schemas.openxmlformats.org/drawingml/2006/main" r:embed="Re274af6892a24fdd">
             <a:alphaModFix/>
           </a:blip>
           <a:srcRect xmlns:a="http://schemas.openxmlformats.org/drawingml/2006/main" l="0" t="0" r="0" b="98001"/>
@@ -10697,7 +10697,7 @@
           <p:cNvPr id="77" name="Google Shape;77;p16">
             <a:extLst xmlns:a="http://schemas.openxmlformats.org/drawingml/2006/main">
               <a:ext uri="{FF2B5EF4-FFF2-40B4-BE49-F238E27FC236}">
-                <a16:creationId xmlns:a16="http://schemas.microsoft.com/office/drawing/2014/main" id="{B89F3E4E-100B-401B-BF75-27159811DEB1}"/>
+                <a16:creationId xmlns:a16="http://schemas.microsoft.com/office/drawing/2014/main" id="{4554820F-2E6B-4E86-B792-204FBE0C1003}"/>
               </a:ext>
             </a:extLst>
           </p:cNvPr>
@@ -10707,7 +10707,7 @@
           <p:nvPr/>
         </p:nvPicPr>
         <p:blipFill>
-          <a:blip xmlns:r="http://schemas.openxmlformats.org/officeDocument/2006/relationships" xmlns:a="http://schemas.openxmlformats.org/drawingml/2006/main" r:embed="Rc0d27c1758704573">
+          <a:blip xmlns:r="http://schemas.openxmlformats.org/officeDocument/2006/relationships" xmlns:a="http://schemas.openxmlformats.org/drawingml/2006/main" r:embed="R95c971555b9544b8">
             <a:alphaModFix/>
           </a:blip>
           <a:stretch xmlns:a="http://schemas.openxmlformats.org/drawingml/2006/main">
@@ -10732,7 +10732,7 @@
           <p:cNvPr id="78" name="Google Shape;78;p16">
             <a:extLst xmlns:a="http://schemas.openxmlformats.org/drawingml/2006/main">
               <a:ext uri="{FF2B5EF4-FFF2-40B4-BE49-F238E27FC236}">
-                <a16:creationId xmlns:a16="http://schemas.microsoft.com/office/drawing/2014/main" id="{88241DDC-45E2-4D12-B240-0665ACCBBC54}"/>
+                <a16:creationId xmlns:a16="http://schemas.microsoft.com/office/drawing/2014/main" id="{396A4839-4E3C-4E7A-A9E5-DD37DB5F939E}"/>
               </a:ext>
             </a:extLst>
           </p:cNvPr>
@@ -10783,7 +10783,7 @@
           <p:cNvPr id="79" name="Google Shape;79;p16">
             <a:extLst xmlns:a="http://schemas.openxmlformats.org/drawingml/2006/main">
               <a:ext uri="{FF2B5EF4-FFF2-40B4-BE49-F238E27FC236}">
-                <a16:creationId xmlns:a16="http://schemas.microsoft.com/office/drawing/2014/main" id="{11348B2A-BD0A-435D-A6F0-409442D01D60}"/>
+                <a16:creationId xmlns:a16="http://schemas.microsoft.com/office/drawing/2014/main" id="{F771316F-7D9F-4A35-B867-18240DD82DE5}"/>
               </a:ext>
             </a:extLst>
           </p:cNvPr>
@@ -10863,7 +10863,7 @@
           <p:cNvPr id="80" name="fit-headline">
             <a:extLst xmlns:a="http://schemas.openxmlformats.org/drawingml/2006/main">
               <a:ext uri="{FF2B5EF4-FFF2-40B4-BE49-F238E27FC236}">
-                <a16:creationId xmlns:a16="http://schemas.microsoft.com/office/drawing/2014/main" id="{E7E12CEF-5BF0-47F1-83FA-8DC8859F79DF}"/>
+                <a16:creationId xmlns:a16="http://schemas.microsoft.com/office/drawing/2014/main" id="{40C727A0-C813-4A5A-9E0B-615A00B770FC}"/>
               </a:ext>
             </a:extLst>
           </p:cNvPr>
@@ -10931,7 +10931,7 @@
           <p:cNvPr id="81" name="observe">
             <a:extLst xmlns:a="http://schemas.openxmlformats.org/drawingml/2006/main">
               <a:ext uri="{FF2B5EF4-FFF2-40B4-BE49-F238E27FC236}">
-                <a16:creationId xmlns:a16="http://schemas.microsoft.com/office/drawing/2014/main" id="{A2DA9B0F-9AA4-4928-A7C2-5987E2C9F606}"/>
+                <a16:creationId xmlns:a16="http://schemas.microsoft.com/office/drawing/2014/main" id="{D80C9814-203B-4101-B949-62480313874C}"/>
               </a:ext>
             </a:extLst>
           </p:cNvPr>
@@ -11026,7 +11026,7 @@
           <p:cNvPr id="82" name="rehearse">
             <a:extLst xmlns:a="http://schemas.openxmlformats.org/drawingml/2006/main">
               <a:ext uri="{FF2B5EF4-FFF2-40B4-BE49-F238E27FC236}">
-                <a16:creationId xmlns:a16="http://schemas.microsoft.com/office/drawing/2014/main" id="{185291BF-BE9C-421D-8B5F-790BF894F169}"/>
+                <a16:creationId xmlns:a16="http://schemas.microsoft.com/office/drawing/2014/main" id="{876CC2A4-E381-4016-B8EF-E195A6994472}"/>
               </a:ext>
             </a:extLst>
           </p:cNvPr>
@@ -11121,7 +11121,7 @@
           <p:cNvPr id="83" name="review">
             <a:extLst xmlns:a="http://schemas.openxmlformats.org/drawingml/2006/main">
               <a:ext uri="{FF2B5EF4-FFF2-40B4-BE49-F238E27FC236}">
-                <a16:creationId xmlns:a16="http://schemas.microsoft.com/office/drawing/2014/main" id="{B759DEE2-2BA5-4DB0-8430-AC9C3C5693E8}"/>
+                <a16:creationId xmlns:a16="http://schemas.microsoft.com/office/drawing/2014/main" id="{4A06ECC4-250E-4970-B3C4-E8473F672B9A}"/>
               </a:ext>
             </a:extLst>
           </p:cNvPr>
@@ -11216,7 +11216,7 @@
           <p:cNvPr id="84" name="apply">
             <a:extLst xmlns:a="http://schemas.openxmlformats.org/drawingml/2006/main">
               <a:ext uri="{FF2B5EF4-FFF2-40B4-BE49-F238E27FC236}">
-                <a16:creationId xmlns:a16="http://schemas.microsoft.com/office/drawing/2014/main" id="{3DFB22F9-626C-47CB-8692-970DF73C60D5}"/>
+                <a16:creationId xmlns:a16="http://schemas.microsoft.com/office/drawing/2014/main" id="{F4D45C60-55BE-4478-9861-5AF62EF74A5B}"/>
               </a:ext>
             </a:extLst>
           </p:cNvPr>
@@ -11311,7 +11311,7 @@
           <p:cNvPr id="88" name="fit-bridge">
             <a:extLst xmlns:a="http://schemas.openxmlformats.org/drawingml/2006/main">
               <a:ext uri="{FF2B5EF4-FFF2-40B4-BE49-F238E27FC236}">
-                <a16:creationId xmlns:a16="http://schemas.microsoft.com/office/drawing/2014/main" id="{7B2DD5D1-CABA-46DB-937D-7D65D0C5963F}"/>
+                <a16:creationId xmlns:a16="http://schemas.microsoft.com/office/drawing/2014/main" id="{A98727A8-3CD7-4F71-A8D4-1E90779DE657}"/>
               </a:ext>
             </a:extLst>
           </p:cNvPr>
@@ -11379,7 +11379,7 @@
           <p:cNvPr id="89" name="fit-bridge2">
             <a:extLst xmlns:a="http://schemas.openxmlformats.org/drawingml/2006/main">
               <a:ext uri="{FF2B5EF4-FFF2-40B4-BE49-F238E27FC236}">
-                <a16:creationId xmlns:a16="http://schemas.microsoft.com/office/drawing/2014/main" id="{7BC43B29-DA95-40CD-8000-4A4C4282BF01}"/>
+                <a16:creationId xmlns:a16="http://schemas.microsoft.com/office/drawing/2014/main" id="{2796A5AD-8357-4DD9-863A-4B61AFA20F31}"/>
               </a:ext>
             </a:extLst>
           </p:cNvPr>
@@ -11447,7 +11447,7 @@
           <p:cNvPr id="90" name="fit-bridge3">
             <a:extLst xmlns:a="http://schemas.openxmlformats.org/drawingml/2006/main">
               <a:ext uri="{FF2B5EF4-FFF2-40B4-BE49-F238E27FC236}">
-                <a16:creationId xmlns:a16="http://schemas.microsoft.com/office/drawing/2014/main" id="{B7923285-80EE-4746-AF63-25803C136D73}"/>
+                <a16:creationId xmlns:a16="http://schemas.microsoft.com/office/drawing/2014/main" id="{165B706C-1768-4CB0-8981-361747FC1B04}"/>
               </a:ext>
             </a:extLst>
           </p:cNvPr>
@@ -11515,7 +11515,7 @@
           <p:cNvPr id="91" name="opportunity-label-0">
             <a:extLst xmlns:a="http://schemas.openxmlformats.org/drawingml/2006/main">
               <a:ext uri="{FF2B5EF4-FFF2-40B4-BE49-F238E27FC236}">
-                <a16:creationId xmlns:a16="http://schemas.microsoft.com/office/drawing/2014/main" id="{1B40767F-6C0C-4935-8BA9-E6CDC400DF1F}"/>
+                <a16:creationId xmlns:a16="http://schemas.microsoft.com/office/drawing/2014/main" id="{6AB607DF-AF88-468F-8279-0B4A16FB843A}"/>
               </a:ext>
             </a:extLst>
           </p:cNvPr>
@@ -11583,7 +11583,7 @@
           <p:cNvPr id="92" name="opportunity-body-0">
             <a:extLst xmlns:a="http://schemas.openxmlformats.org/drawingml/2006/main">
               <a:ext uri="{FF2B5EF4-FFF2-40B4-BE49-F238E27FC236}">
-                <a16:creationId xmlns:a16="http://schemas.microsoft.com/office/drawing/2014/main" id="{8E57EECD-0685-4AC0-8177-15870E06A751}"/>
+                <a16:creationId xmlns:a16="http://schemas.microsoft.com/office/drawing/2014/main" id="{7C725730-0229-47E1-A1C1-B6C461DE434A}"/>
               </a:ext>
             </a:extLst>
           </p:cNvPr>
@@ -11651,7 +11651,7 @@
           <p:cNvPr id="93" name="opportunity-label-1">
             <a:extLst xmlns:a="http://schemas.openxmlformats.org/drawingml/2006/main">
               <a:ext uri="{FF2B5EF4-FFF2-40B4-BE49-F238E27FC236}">
-                <a16:creationId xmlns:a16="http://schemas.microsoft.com/office/drawing/2014/main" id="{69BE745E-39B3-44CC-B340-F24576CAAAC8}"/>
+                <a16:creationId xmlns:a16="http://schemas.microsoft.com/office/drawing/2014/main" id="{13B0AA5C-21B5-4465-95F8-BDE206DB3F86}"/>
               </a:ext>
             </a:extLst>
           </p:cNvPr>
@@ -11719,7 +11719,7 @@
           <p:cNvPr id="94" name="opportunity-body-1">
             <a:extLst xmlns:a="http://schemas.openxmlformats.org/drawingml/2006/main">
               <a:ext uri="{FF2B5EF4-FFF2-40B4-BE49-F238E27FC236}">
-                <a16:creationId xmlns:a16="http://schemas.microsoft.com/office/drawing/2014/main" id="{3C184ACE-4E4E-4E89-93B4-B4E960D5879B}"/>
+                <a16:creationId xmlns:a16="http://schemas.microsoft.com/office/drawing/2014/main" id="{67E37640-674D-46BB-9E96-3FEC87B056AB}"/>
               </a:ext>
             </a:extLst>
           </p:cNvPr>
@@ -11787,7 +11787,7 @@
           <p:cNvPr id="95" name="opportunity-label-2">
             <a:extLst xmlns:a="http://schemas.openxmlformats.org/drawingml/2006/main">
               <a:ext uri="{FF2B5EF4-FFF2-40B4-BE49-F238E27FC236}">
-                <a16:creationId xmlns:a16="http://schemas.microsoft.com/office/drawing/2014/main" id="{3ACA5D6B-D9C5-441A-98B5-2187E7AFBCD3}"/>
+                <a16:creationId xmlns:a16="http://schemas.microsoft.com/office/drawing/2014/main" id="{A0AF64D8-7F9F-42B3-9979-C79D96B1DBBB}"/>
               </a:ext>
             </a:extLst>
           </p:cNvPr>
@@ -11855,7 +11855,7 @@
           <p:cNvPr id="96" name="opportunity-body-2">
             <a:extLst xmlns:a="http://schemas.openxmlformats.org/drawingml/2006/main">
               <a:ext uri="{FF2B5EF4-FFF2-40B4-BE49-F238E27FC236}">
-                <a16:creationId xmlns:a16="http://schemas.microsoft.com/office/drawing/2014/main" id="{AC8CA2C3-CBB8-4851-88F7-85D2703173ED}"/>
+                <a16:creationId xmlns:a16="http://schemas.microsoft.com/office/drawing/2014/main" id="{7BA8A96C-76CC-4444-B49F-3C8B7C29A51C}"/>
               </a:ext>
             </a:extLst>
           </p:cNvPr>
@@ -11921,7 +11921,7 @@
     </p:spTree>
     <p:extLst>
       <p:ext uri="{BB962C8B-B14F-4D97-AF65-F5344CB8AC3E}">
-        <p14:creationId xmlns:p14="http://schemas.microsoft.com/office/powerpoint/2010/main" val="2105344319"/>
+        <p14:creationId xmlns:p14="http://schemas.microsoft.com/office/powerpoint/2010/main" val="1964628070"/>
       </p:ext>
     </p:extLst>
   </p:cSld>
@@ -11945,7 +11945,7 @@
           <p:cNvPr id="84" name="Google Shape;84;p17">
             <a:extLst xmlns:a="http://schemas.openxmlformats.org/drawingml/2006/main">
               <a:ext uri="{FF2B5EF4-FFF2-40B4-BE49-F238E27FC236}">
-                <a16:creationId xmlns:a16="http://schemas.microsoft.com/office/drawing/2014/main" id="{20D3920F-3381-43E7-9672-190F587E62DE}"/>
+                <a16:creationId xmlns:a16="http://schemas.microsoft.com/office/drawing/2014/main" id="{0D8F10ED-D84A-478B-8823-84CA06FD1A27}"/>
               </a:ext>
             </a:extLst>
           </p:cNvPr>
@@ -11955,7 +11955,7 @@
           <p:nvPr/>
         </p:nvPicPr>
         <p:blipFill rotWithShape="1">
-          <a:blip xmlns:r="http://schemas.openxmlformats.org/officeDocument/2006/relationships" xmlns:a="http://schemas.openxmlformats.org/drawingml/2006/main" r:embed="Rc8ea1290e61b4316">
+          <a:blip xmlns:r="http://schemas.openxmlformats.org/officeDocument/2006/relationships" xmlns:a="http://schemas.openxmlformats.org/drawingml/2006/main" r:embed="Rc7d885f9831d4819">
             <a:alphaModFix/>
           </a:blip>
           <a:srcRect xmlns:a="http://schemas.openxmlformats.org/drawingml/2006/main" l="0" t="0" r="0" b="98001"/>
@@ -11979,7 +11979,7 @@
           <p:cNvPr id="85" name="Google Shape;85;p17">
             <a:extLst xmlns:a="http://schemas.openxmlformats.org/drawingml/2006/main">
               <a:ext uri="{FF2B5EF4-FFF2-40B4-BE49-F238E27FC236}">
-                <a16:creationId xmlns:a16="http://schemas.microsoft.com/office/drawing/2014/main" id="{AB18B8F4-9AE7-4474-ADEB-B2CD2F1EE491}"/>
+                <a16:creationId xmlns:a16="http://schemas.microsoft.com/office/drawing/2014/main" id="{0963FC21-87B7-4F95-974B-FEAD9D15244B}"/>
               </a:ext>
             </a:extLst>
           </p:cNvPr>
@@ -11989,7 +11989,7 @@
           <p:nvPr/>
         </p:nvPicPr>
         <p:blipFill>
-          <a:blip xmlns:r="http://schemas.openxmlformats.org/officeDocument/2006/relationships" xmlns:a="http://schemas.openxmlformats.org/drawingml/2006/main" r:embed="R69b83d84bfc14d05">
+          <a:blip xmlns:r="http://schemas.openxmlformats.org/officeDocument/2006/relationships" xmlns:a="http://schemas.openxmlformats.org/drawingml/2006/main" r:embed="R259df2bd01e247f2">
             <a:alphaModFix/>
           </a:blip>
           <a:stretch xmlns:a="http://schemas.openxmlformats.org/drawingml/2006/main">
@@ -12014,7 +12014,7 @@
           <p:cNvPr id="86" name="Google Shape;86;p17">
             <a:extLst xmlns:a="http://schemas.openxmlformats.org/drawingml/2006/main">
               <a:ext uri="{FF2B5EF4-FFF2-40B4-BE49-F238E27FC236}">
-                <a16:creationId xmlns:a16="http://schemas.microsoft.com/office/drawing/2014/main" id="{1E70009D-4799-4771-9FDA-52820ACB7BFE}"/>
+                <a16:creationId xmlns:a16="http://schemas.microsoft.com/office/drawing/2014/main" id="{686ED5E0-7D1E-4BB9-90E7-2A4152F58EA9}"/>
               </a:ext>
             </a:extLst>
           </p:cNvPr>
@@ -12065,7 +12065,7 @@
           <p:cNvPr id="87" name="Google Shape;87;p17">
             <a:extLst xmlns:a="http://schemas.openxmlformats.org/drawingml/2006/main">
               <a:ext uri="{FF2B5EF4-FFF2-40B4-BE49-F238E27FC236}">
-                <a16:creationId xmlns:a16="http://schemas.microsoft.com/office/drawing/2014/main" id="{892BA722-EB65-4D24-B37B-60E83D8CDEC4}"/>
+                <a16:creationId xmlns:a16="http://schemas.microsoft.com/office/drawing/2014/main" id="{B8FCE646-F9D3-45CD-8360-0A68A3417246}"/>
               </a:ext>
             </a:extLst>
           </p:cNvPr>
@@ -12145,7 +12145,7 @@
           <p:cNvPr id="88" name="feature-summary">
             <a:extLst xmlns:a="http://schemas.openxmlformats.org/drawingml/2006/main">
               <a:ext uri="{FF2B5EF4-FFF2-40B4-BE49-F238E27FC236}">
-                <a16:creationId xmlns:a16="http://schemas.microsoft.com/office/drawing/2014/main" id="{42CA8497-7772-4A78-BD01-5EABE7F4B1FA}"/>
+                <a16:creationId xmlns:a16="http://schemas.microsoft.com/office/drawing/2014/main" id="{083EA2DE-9FC4-4623-8697-A09F41751350}"/>
               </a:ext>
             </a:extLst>
           </p:cNvPr>
@@ -12213,7 +12213,7 @@
           <p:cNvPr id="89" name="feature-scope">
             <a:extLst xmlns:a="http://schemas.openxmlformats.org/drawingml/2006/main">
               <a:ext uri="{FF2B5EF4-FFF2-40B4-BE49-F238E27FC236}">
-                <a16:creationId xmlns:a16="http://schemas.microsoft.com/office/drawing/2014/main" id="{689EE448-1AAE-4EE6-A2F5-BED3755369D5}"/>
+                <a16:creationId xmlns:a16="http://schemas.microsoft.com/office/drawing/2014/main" id="{5A98D176-4DE4-4A15-9D1B-C0FDFA2AD329}"/>
               </a:ext>
             </a:extLst>
           </p:cNvPr>
@@ -12281,7 +12281,7 @@
           <p:cNvPr id="90" name="">
             <a:extLst xmlns:a="http://schemas.openxmlformats.org/drawingml/2006/main">
               <a:ext uri="{FF2B5EF4-FFF2-40B4-BE49-F238E27FC236}">
-                <a16:creationId xmlns:a16="http://schemas.microsoft.com/office/drawing/2014/main" id="{2EEA3187-86AD-4263-A983-FBE9024C2121}"/>
+                <a16:creationId xmlns:a16="http://schemas.microsoft.com/office/drawing/2014/main" id="{C956D85F-1F24-47E5-AA53-AB8A409A052A}"/>
               </a:ext>
             </a:extLst>
           </p:cNvPr>
@@ -12815,7 +12815,7 @@
           <p:cNvPr id="91" name="feature-takeaway">
             <a:extLst xmlns:a="http://schemas.openxmlformats.org/drawingml/2006/main">
               <a:ext uri="{FF2B5EF4-FFF2-40B4-BE49-F238E27FC236}">
-                <a16:creationId xmlns:a16="http://schemas.microsoft.com/office/drawing/2014/main" id="{61E769E2-F01B-4F0C-AEC6-92DF0C342DC5}"/>
+                <a16:creationId xmlns:a16="http://schemas.microsoft.com/office/drawing/2014/main" id="{7C49FDD9-26A9-4655-AFEE-6D2D5CE8A77B}"/>
               </a:ext>
             </a:extLst>
           </p:cNvPr>
@@ -12883,7 +12883,7 @@
           <p:cNvPr id="92" name="feature-tail">
             <a:extLst xmlns:a="http://schemas.openxmlformats.org/drawingml/2006/main">
               <a:ext uri="{FF2B5EF4-FFF2-40B4-BE49-F238E27FC236}">
-                <a16:creationId xmlns:a16="http://schemas.microsoft.com/office/drawing/2014/main" id="{87D83D0D-A259-4B16-9748-E95DE2BD2B50}"/>
+                <a16:creationId xmlns:a16="http://schemas.microsoft.com/office/drawing/2014/main" id="{62CDB942-1FDF-4FA9-950D-88C5F595CFDD}"/>
               </a:ext>
             </a:extLst>
           </p:cNvPr>
@@ -12949,7 +12949,7 @@
     </p:spTree>
     <p:extLst>
       <p:ext uri="{BB962C8B-B14F-4D97-AF65-F5344CB8AC3E}">
-        <p14:creationId xmlns:p14="http://schemas.microsoft.com/office/powerpoint/2010/main" val="1617196538"/>
+        <p14:creationId xmlns:p14="http://schemas.microsoft.com/office/powerpoint/2010/main" val="902136907"/>
       </p:ext>
     </p:extLst>
   </p:cSld>
@@ -12973,7 +12973,7 @@
           <p:cNvPr id="112" name="">
             <a:extLst xmlns:a="http://schemas.openxmlformats.org/drawingml/2006/main">
               <a:ext uri="{FF2B5EF4-FFF2-40B4-BE49-F238E27FC236}">
-                <a16:creationId xmlns:a16="http://schemas.microsoft.com/office/drawing/2014/main" id="{C645E2BF-8CEA-4604-9E24-C19B8BFFAF18}"/>
+                <a16:creationId xmlns:a16="http://schemas.microsoft.com/office/drawing/2014/main" id="{9696727A-88B2-4FE1-8DDA-73AF5AF460AD}"/>
               </a:ext>
             </a:extLst>
           </p:cNvPr>
@@ -13004,7 +13004,7 @@
           <p:cNvPr id="111" name="">
             <a:extLst xmlns:a="http://schemas.openxmlformats.org/drawingml/2006/main">
               <a:ext uri="{FF2B5EF4-FFF2-40B4-BE49-F238E27FC236}">
-                <a16:creationId xmlns:a16="http://schemas.microsoft.com/office/drawing/2014/main" id="{4D18DD40-9979-43E6-8E81-189F6AB264BC}"/>
+                <a16:creationId xmlns:a16="http://schemas.microsoft.com/office/drawing/2014/main" id="{777B5ABB-4D46-4686-9BCB-A64B381A4105}"/>
               </a:ext>
             </a:extLst>
           </p:cNvPr>
@@ -13035,7 +13035,7 @@
           <p:cNvPr id="110" name="">
             <a:extLst xmlns:a="http://schemas.openxmlformats.org/drawingml/2006/main">
               <a:ext uri="{FF2B5EF4-FFF2-40B4-BE49-F238E27FC236}">
-                <a16:creationId xmlns:a16="http://schemas.microsoft.com/office/drawing/2014/main" id="{94C14AA6-702B-4BC7-AD0C-12E206E47867}"/>
+                <a16:creationId xmlns:a16="http://schemas.microsoft.com/office/drawing/2014/main" id="{7918FFE3-8CFA-412B-B2B8-93A6C3CEFFE7}"/>
               </a:ext>
             </a:extLst>
           </p:cNvPr>
@@ -13066,7 +13066,7 @@
           <p:cNvPr id="109" name="">
             <a:extLst xmlns:a="http://schemas.openxmlformats.org/drawingml/2006/main">
               <a:ext uri="{FF2B5EF4-FFF2-40B4-BE49-F238E27FC236}">
-                <a16:creationId xmlns:a16="http://schemas.microsoft.com/office/drawing/2014/main" id="{9406820D-F1FD-4E5D-8440-4937BFBD092B}"/>
+                <a16:creationId xmlns:a16="http://schemas.microsoft.com/office/drawing/2014/main" id="{C2F0EF57-BDDE-4853-AC09-DA7B1D76AA57}"/>
               </a:ext>
             </a:extLst>
           </p:cNvPr>
@@ -13097,7 +13097,7 @@
           <p:cNvPr id="104" name="">
             <a:extLst xmlns:a="http://schemas.openxmlformats.org/drawingml/2006/main">
               <a:ext uri="{FF2B5EF4-FFF2-40B4-BE49-F238E27FC236}">
-                <a16:creationId xmlns:a16="http://schemas.microsoft.com/office/drawing/2014/main" id="{014F874C-0444-4959-A72C-91EC2F43047A}"/>
+                <a16:creationId xmlns:a16="http://schemas.microsoft.com/office/drawing/2014/main" id="{05FC33CA-579D-412A-951A-5228E2AAF31E}"/>
               </a:ext>
             </a:extLst>
           </p:cNvPr>
@@ -13128,7 +13128,7 @@
           <p:cNvPr id="103" name="">
             <a:extLst xmlns:a="http://schemas.openxmlformats.org/drawingml/2006/main">
               <a:ext uri="{FF2B5EF4-FFF2-40B4-BE49-F238E27FC236}">
-                <a16:creationId xmlns:a16="http://schemas.microsoft.com/office/drawing/2014/main" id="{4C34D965-90CD-4395-8B0F-319472ED8133}"/>
+                <a16:creationId xmlns:a16="http://schemas.microsoft.com/office/drawing/2014/main" id="{D2148BBB-6F7C-4BC4-8726-DCB7ED280704}"/>
               </a:ext>
             </a:extLst>
           </p:cNvPr>
@@ -13159,7 +13159,7 @@
           <p:cNvPr id="102" name="">
             <a:extLst xmlns:a="http://schemas.openxmlformats.org/drawingml/2006/main">
               <a:ext uri="{FF2B5EF4-FFF2-40B4-BE49-F238E27FC236}">
-                <a16:creationId xmlns:a16="http://schemas.microsoft.com/office/drawing/2014/main" id="{A5A9C3B9-39BD-4956-88D8-D7FEC795CD5C}"/>
+                <a16:creationId xmlns:a16="http://schemas.microsoft.com/office/drawing/2014/main" id="{D870EBDC-BE91-439D-9930-2ADEE25272C7}"/>
               </a:ext>
             </a:extLst>
           </p:cNvPr>
@@ -13190,7 +13190,7 @@
           <p:cNvPr id="92" name="Google Shape;92;p18">
             <a:extLst xmlns:a="http://schemas.openxmlformats.org/drawingml/2006/main">
               <a:ext uri="{FF2B5EF4-FFF2-40B4-BE49-F238E27FC236}">
-                <a16:creationId xmlns:a16="http://schemas.microsoft.com/office/drawing/2014/main" id="{AF59E8AF-7451-4F77-A48B-1AFDE5169D5C}"/>
+                <a16:creationId xmlns:a16="http://schemas.microsoft.com/office/drawing/2014/main" id="{0E32224C-7E7D-48FA-A144-60182B1FBC31}"/>
               </a:ext>
             </a:extLst>
           </p:cNvPr>
@@ -13200,7 +13200,7 @@
           <p:nvPr/>
         </p:nvPicPr>
         <p:blipFill rotWithShape="1">
-          <a:blip xmlns:r="http://schemas.openxmlformats.org/officeDocument/2006/relationships" xmlns:a="http://schemas.openxmlformats.org/drawingml/2006/main" r:embed="R38da7c7fe20f40b9">
+          <a:blip xmlns:r="http://schemas.openxmlformats.org/officeDocument/2006/relationships" xmlns:a="http://schemas.openxmlformats.org/drawingml/2006/main" r:embed="R6b9c19c5d2d843be">
             <a:alphaModFix/>
           </a:blip>
           <a:srcRect xmlns:a="http://schemas.openxmlformats.org/drawingml/2006/main" l="0" t="0" r="0" b="98001"/>
@@ -13224,7 +13224,7 @@
           <p:cNvPr id="93" name="Google Shape;93;p18">
             <a:extLst xmlns:a="http://schemas.openxmlformats.org/drawingml/2006/main">
               <a:ext uri="{FF2B5EF4-FFF2-40B4-BE49-F238E27FC236}">
-                <a16:creationId xmlns:a16="http://schemas.microsoft.com/office/drawing/2014/main" id="{B6A906D7-6D01-4665-B46F-27E46DFA363B}"/>
+                <a16:creationId xmlns:a16="http://schemas.microsoft.com/office/drawing/2014/main" id="{70BEF444-CA8A-4895-AE1B-564F8AA0E647}"/>
               </a:ext>
             </a:extLst>
           </p:cNvPr>
@@ -13234,7 +13234,7 @@
           <p:nvPr/>
         </p:nvPicPr>
         <p:blipFill>
-          <a:blip xmlns:r="http://schemas.openxmlformats.org/officeDocument/2006/relationships" xmlns:a="http://schemas.openxmlformats.org/drawingml/2006/main" r:embed="Rd4ce2b3d332542b7">
+          <a:blip xmlns:r="http://schemas.openxmlformats.org/officeDocument/2006/relationships" xmlns:a="http://schemas.openxmlformats.org/drawingml/2006/main" r:embed="Red91808a7f8746f7">
             <a:alphaModFix/>
           </a:blip>
           <a:stretch xmlns:a="http://schemas.openxmlformats.org/drawingml/2006/main">
@@ -13259,7 +13259,7 @@
           <p:cNvPr id="94" name="Google Shape;94;p18">
             <a:extLst xmlns:a="http://schemas.openxmlformats.org/drawingml/2006/main">
               <a:ext uri="{FF2B5EF4-FFF2-40B4-BE49-F238E27FC236}">
-                <a16:creationId xmlns:a16="http://schemas.microsoft.com/office/drawing/2014/main" id="{C466D09E-297E-4E02-BE89-F84837E682A0}"/>
+                <a16:creationId xmlns:a16="http://schemas.microsoft.com/office/drawing/2014/main" id="{8F3EAF1A-8254-449A-A53C-DDA5D73B93C0}"/>
               </a:ext>
             </a:extLst>
           </p:cNvPr>
@@ -13310,7 +13310,7 @@
           <p:cNvPr id="95" name="Google Shape;95;p18">
             <a:extLst xmlns:a="http://schemas.openxmlformats.org/drawingml/2006/main">
               <a:ext uri="{FF2B5EF4-FFF2-40B4-BE49-F238E27FC236}">
-                <a16:creationId xmlns:a16="http://schemas.microsoft.com/office/drawing/2014/main" id="{24D5C3B4-60BB-404D-ADD0-697E2CB573BA}"/>
+                <a16:creationId xmlns:a16="http://schemas.microsoft.com/office/drawing/2014/main" id="{D3908975-B3DA-4D38-BBCC-252FA9096564}"/>
               </a:ext>
             </a:extLst>
           </p:cNvPr>
@@ -13390,7 +13390,7 @@
           <p:cNvPr id="96" name="flow-headline">
             <a:extLst xmlns:a="http://schemas.openxmlformats.org/drawingml/2006/main">
               <a:ext uri="{FF2B5EF4-FFF2-40B4-BE49-F238E27FC236}">
-                <a16:creationId xmlns:a16="http://schemas.microsoft.com/office/drawing/2014/main" id="{9C35EDF0-B854-4157-A5F5-6D1A4E47738F}"/>
+                <a16:creationId xmlns:a16="http://schemas.microsoft.com/office/drawing/2014/main" id="{1DFB8AC2-333B-4415-BA65-4DE28D68BD1C}"/>
               </a:ext>
             </a:extLst>
           </p:cNvPr>
@@ -13458,7 +13458,7 @@
           <p:cNvPr id="97" name="flow-test-label">
             <a:extLst xmlns:a="http://schemas.openxmlformats.org/drawingml/2006/main">
               <a:ext uri="{FF2B5EF4-FFF2-40B4-BE49-F238E27FC236}">
-                <a16:creationId xmlns:a16="http://schemas.microsoft.com/office/drawing/2014/main" id="{43CB11D8-F6CA-409F-A4D3-5DA505D0C73F}"/>
+                <a16:creationId xmlns:a16="http://schemas.microsoft.com/office/drawing/2014/main" id="{FAF775D2-420B-4623-9A50-B174C24E8F35}"/>
               </a:ext>
             </a:extLst>
           </p:cNvPr>
@@ -13526,7 +13526,7 @@
           <p:cNvPr id="98" name="flow-1">
             <a:extLst xmlns:a="http://schemas.openxmlformats.org/drawingml/2006/main">
               <a:ext uri="{FF2B5EF4-FFF2-40B4-BE49-F238E27FC236}">
-                <a16:creationId xmlns:a16="http://schemas.microsoft.com/office/drawing/2014/main" id="{E7C6EB7C-A397-49E5-9F6B-144C340A48A4}"/>
+                <a16:creationId xmlns:a16="http://schemas.microsoft.com/office/drawing/2014/main" id="{9B1D7036-D98F-4BCC-90A2-6E200A3C0FF3}"/>
               </a:ext>
             </a:extLst>
           </p:cNvPr>
@@ -13621,7 +13621,7 @@
           <p:cNvPr id="99" name="flow-2">
             <a:extLst xmlns:a="http://schemas.openxmlformats.org/drawingml/2006/main">
               <a:ext uri="{FF2B5EF4-FFF2-40B4-BE49-F238E27FC236}">
-                <a16:creationId xmlns:a16="http://schemas.microsoft.com/office/drawing/2014/main" id="{3A82E6FE-8D9A-4FEF-9C37-A3C9B6DBB752}"/>
+                <a16:creationId xmlns:a16="http://schemas.microsoft.com/office/drawing/2014/main" id="{E1146209-E6ED-47FA-BF64-1D21B5C38733}"/>
               </a:ext>
             </a:extLst>
           </p:cNvPr>
@@ -13716,7 +13716,7 @@
           <p:cNvPr id="100" name="flow-3">
             <a:extLst xmlns:a="http://schemas.openxmlformats.org/drawingml/2006/main">
               <a:ext uri="{FF2B5EF4-FFF2-40B4-BE49-F238E27FC236}">
-                <a16:creationId xmlns:a16="http://schemas.microsoft.com/office/drawing/2014/main" id="{181D43D7-FCBC-4D4E-8A63-36F00C6E02B2}"/>
+                <a16:creationId xmlns:a16="http://schemas.microsoft.com/office/drawing/2014/main" id="{FBC8433B-F97B-4F7B-8B98-1731BDA309E7}"/>
               </a:ext>
             </a:extLst>
           </p:cNvPr>
@@ -13811,7 +13811,7 @@
           <p:cNvPr id="101" name="flow-4">
             <a:extLst xmlns:a="http://schemas.openxmlformats.org/drawingml/2006/main">
               <a:ext uri="{FF2B5EF4-FFF2-40B4-BE49-F238E27FC236}">
-                <a16:creationId xmlns:a16="http://schemas.microsoft.com/office/drawing/2014/main" id="{75FEE7FC-3D73-4AC3-8D43-46908C63A057}"/>
+                <a16:creationId xmlns:a16="http://schemas.microsoft.com/office/drawing/2014/main" id="{F205E2F0-847F-4891-8758-851BD5028031}"/>
               </a:ext>
             </a:extLst>
           </p:cNvPr>
@@ -13906,7 +13906,7 @@
           <p:cNvPr id="105" name="flow-8">
             <a:extLst xmlns:a="http://schemas.openxmlformats.org/drawingml/2006/main">
               <a:ext uri="{FF2B5EF4-FFF2-40B4-BE49-F238E27FC236}">
-                <a16:creationId xmlns:a16="http://schemas.microsoft.com/office/drawing/2014/main" id="{AD09A971-2395-4BE8-98DB-34233016BD6C}"/>
+                <a16:creationId xmlns:a16="http://schemas.microsoft.com/office/drawing/2014/main" id="{F46F1599-78E7-4FAF-9283-AF92CF1F4EE4}"/>
               </a:ext>
             </a:extLst>
           </p:cNvPr>
@@ -14001,7 +14001,7 @@
           <p:cNvPr id="106" name="flow-7">
             <a:extLst xmlns:a="http://schemas.openxmlformats.org/drawingml/2006/main">
               <a:ext uri="{FF2B5EF4-FFF2-40B4-BE49-F238E27FC236}">
-                <a16:creationId xmlns:a16="http://schemas.microsoft.com/office/drawing/2014/main" id="{E553B86B-7EC1-4FCA-9C53-86237103118B}"/>
+                <a16:creationId xmlns:a16="http://schemas.microsoft.com/office/drawing/2014/main" id="{8976D58B-6292-4F92-9B97-0958119F659A}"/>
               </a:ext>
             </a:extLst>
           </p:cNvPr>
@@ -14096,7 +14096,7 @@
           <p:cNvPr id="107" name="flow-6">
             <a:extLst xmlns:a="http://schemas.openxmlformats.org/drawingml/2006/main">
               <a:ext uri="{FF2B5EF4-FFF2-40B4-BE49-F238E27FC236}">
-                <a16:creationId xmlns:a16="http://schemas.microsoft.com/office/drawing/2014/main" id="{BED6EBDA-B4C9-4A8F-B45B-2227A79D4199}"/>
+                <a16:creationId xmlns:a16="http://schemas.microsoft.com/office/drawing/2014/main" id="{8E816124-0327-45B0-AAC9-E792364F12DD}"/>
               </a:ext>
             </a:extLst>
           </p:cNvPr>
@@ -14191,7 +14191,7 @@
           <p:cNvPr id="108" name="flow-5">
             <a:extLst xmlns:a="http://schemas.openxmlformats.org/drawingml/2006/main">
               <a:ext uri="{FF2B5EF4-FFF2-40B4-BE49-F238E27FC236}">
-                <a16:creationId xmlns:a16="http://schemas.microsoft.com/office/drawing/2014/main" id="{EE0C19A3-7310-4CB9-8652-CE918C7C8A17}"/>
+                <a16:creationId xmlns:a16="http://schemas.microsoft.com/office/drawing/2014/main" id="{BE00E841-EFF7-4B50-ACB7-FD5C7960D243}"/>
               </a:ext>
             </a:extLst>
           </p:cNvPr>
@@ -14286,7 +14286,7 @@
           <p:cNvPr id="113" name="flow-turn">
             <a:extLst xmlns:a="http://schemas.openxmlformats.org/drawingml/2006/main">
               <a:ext uri="{FF2B5EF4-FFF2-40B4-BE49-F238E27FC236}">
-                <a16:creationId xmlns:a16="http://schemas.microsoft.com/office/drawing/2014/main" id="{F44461FA-0ACD-4F23-8761-FC3135918D52}"/>
+                <a16:creationId xmlns:a16="http://schemas.microsoft.com/office/drawing/2014/main" id="{EC0FACCA-0FC6-437A-85D6-F0F0A3F7DEBB}"/>
               </a:ext>
             </a:extLst>
           </p:cNvPr>
@@ -14354,7 +14354,7 @@
           <p:cNvPr id="114" name="flow-rule">
             <a:extLst xmlns:a="http://schemas.openxmlformats.org/drawingml/2006/main">
               <a:ext uri="{FF2B5EF4-FFF2-40B4-BE49-F238E27FC236}">
-                <a16:creationId xmlns:a16="http://schemas.microsoft.com/office/drawing/2014/main" id="{128F4313-7CA9-42B7-A8B1-7E08E7435FA1}"/>
+                <a16:creationId xmlns:a16="http://schemas.microsoft.com/office/drawing/2014/main" id="{20438A50-0FF6-4200-93B7-503C2887E451}"/>
               </a:ext>
             </a:extLst>
           </p:cNvPr>
@@ -14420,7 +14420,7 @@
     </p:spTree>
     <p:extLst>
       <p:ext uri="{BB962C8B-B14F-4D97-AF65-F5344CB8AC3E}">
-        <p14:creationId xmlns:p14="http://schemas.microsoft.com/office/powerpoint/2010/main" val="1314682021"/>
+        <p14:creationId xmlns:p14="http://schemas.microsoft.com/office/powerpoint/2010/main" val="151971987"/>
       </p:ext>
     </p:extLst>
   </p:cSld>
@@ -14444,7 +14444,7 @@
           <p:cNvPr id="100" name="Google Shape;100;p19">
             <a:extLst xmlns:a="http://schemas.openxmlformats.org/drawingml/2006/main">
               <a:ext uri="{FF2B5EF4-FFF2-40B4-BE49-F238E27FC236}">
-                <a16:creationId xmlns:a16="http://schemas.microsoft.com/office/drawing/2014/main" id="{69855A37-2AB4-419C-A25E-D298DA954842}"/>
+                <a16:creationId xmlns:a16="http://schemas.microsoft.com/office/drawing/2014/main" id="{F67405F7-0D5F-4677-B00A-D498765D0827}"/>
               </a:ext>
             </a:extLst>
           </p:cNvPr>
@@ -14454,7 +14454,7 @@
           <p:nvPr/>
         </p:nvPicPr>
         <p:blipFill rotWithShape="1">
-          <a:blip xmlns:r="http://schemas.openxmlformats.org/officeDocument/2006/relationships" xmlns:a="http://schemas.openxmlformats.org/drawingml/2006/main" r:embed="R64b8e1e2fe554ef0">
+          <a:blip xmlns:r="http://schemas.openxmlformats.org/officeDocument/2006/relationships" xmlns:a="http://schemas.openxmlformats.org/drawingml/2006/main" r:embed="Refd69a0024a34a85">
             <a:alphaModFix/>
           </a:blip>
           <a:srcRect xmlns:a="http://schemas.openxmlformats.org/drawingml/2006/main" l="0" t="0" r="0" b="98001"/>
@@ -14478,7 +14478,7 @@
           <p:cNvPr id="101" name="Google Shape;101;p19">
             <a:extLst xmlns:a="http://schemas.openxmlformats.org/drawingml/2006/main">
               <a:ext uri="{FF2B5EF4-FFF2-40B4-BE49-F238E27FC236}">
-                <a16:creationId xmlns:a16="http://schemas.microsoft.com/office/drawing/2014/main" id="{BCFC8FE8-3244-4DEA-A00A-3B1CD399C276}"/>
+                <a16:creationId xmlns:a16="http://schemas.microsoft.com/office/drawing/2014/main" id="{6C3DEBF8-9225-4C2D-A307-5F8AB34B0CBB}"/>
               </a:ext>
             </a:extLst>
           </p:cNvPr>
@@ -14488,7 +14488,7 @@
           <p:nvPr/>
         </p:nvPicPr>
         <p:blipFill>
-          <a:blip xmlns:r="http://schemas.openxmlformats.org/officeDocument/2006/relationships" xmlns:a="http://schemas.openxmlformats.org/drawingml/2006/main" r:embed="R1a71814b29664f93">
+          <a:blip xmlns:r="http://schemas.openxmlformats.org/officeDocument/2006/relationships" xmlns:a="http://schemas.openxmlformats.org/drawingml/2006/main" r:embed="R6a1887c342c04c68">
             <a:alphaModFix/>
           </a:blip>
           <a:stretch xmlns:a="http://schemas.openxmlformats.org/drawingml/2006/main">
@@ -14513,7 +14513,7 @@
           <p:cNvPr id="102" name="Google Shape;102;p19">
             <a:extLst xmlns:a="http://schemas.openxmlformats.org/drawingml/2006/main">
               <a:ext uri="{FF2B5EF4-FFF2-40B4-BE49-F238E27FC236}">
-                <a16:creationId xmlns:a16="http://schemas.microsoft.com/office/drawing/2014/main" id="{4F2542C8-B734-46DC-9AC6-06A88E734BEA}"/>
+                <a16:creationId xmlns:a16="http://schemas.microsoft.com/office/drawing/2014/main" id="{A95AB678-A7C9-435A-BF91-35008E5AA049}"/>
               </a:ext>
             </a:extLst>
           </p:cNvPr>
@@ -14564,7 +14564,7 @@
           <p:cNvPr id="103" name="Google Shape;103;p19">
             <a:extLst xmlns:a="http://schemas.openxmlformats.org/drawingml/2006/main">
               <a:ext uri="{FF2B5EF4-FFF2-40B4-BE49-F238E27FC236}">
-                <a16:creationId xmlns:a16="http://schemas.microsoft.com/office/drawing/2014/main" id="{6BA603E1-6CA0-4AF1-AC52-248827D47BAE}"/>
+                <a16:creationId xmlns:a16="http://schemas.microsoft.com/office/drawing/2014/main" id="{3B8F5319-B8D9-4350-801C-7C49A14EE4EB}"/>
               </a:ext>
             </a:extLst>
           </p:cNvPr>
@@ -14644,7 +14644,7 @@
           <p:cNvPr id="104" name="review-headline">
             <a:extLst xmlns:a="http://schemas.openxmlformats.org/drawingml/2006/main">
               <a:ext uri="{FF2B5EF4-FFF2-40B4-BE49-F238E27FC236}">
-                <a16:creationId xmlns:a16="http://schemas.microsoft.com/office/drawing/2014/main" id="{3BFE4A6F-7C18-48E4-967C-559E809EE265}"/>
+                <a16:creationId xmlns:a16="http://schemas.microsoft.com/office/drawing/2014/main" id="{A1039909-7B8A-4FDD-AC80-2439A7B36B48}"/>
               </a:ext>
             </a:extLst>
           </p:cNvPr>
@@ -14712,7 +14712,7 @@
           <p:cNvPr id="105" name="">
             <a:extLst xmlns:a="http://schemas.openxmlformats.org/drawingml/2006/main">
               <a:ext uri="{FF2B5EF4-FFF2-40B4-BE49-F238E27FC236}">
-                <a16:creationId xmlns:a16="http://schemas.microsoft.com/office/drawing/2014/main" id="{9913C375-9B1E-4F6C-92C0-7A8638321866}"/>
+                <a16:creationId xmlns:a16="http://schemas.microsoft.com/office/drawing/2014/main" id="{E1E92C09-3B91-4705-86F3-59013CAB792D}"/>
               </a:ext>
             </a:extLst>
           </p:cNvPr>
@@ -14722,7 +14722,7 @@
           <p:nvPr/>
         </p:nvPicPr>
         <p:blipFill>
-          <a:blip xmlns:r="http://schemas.openxmlformats.org/officeDocument/2006/relationships" xmlns:a="http://schemas.openxmlformats.org/drawingml/2006/main" r:embed="R9861b08f6ff14209"/>
+          <a:blip xmlns:r="http://schemas.openxmlformats.org/officeDocument/2006/relationships" xmlns:a="http://schemas.openxmlformats.org/drawingml/2006/main" r:embed="R9f26d49f772b407f"/>
           <a:srcRect xmlns:a="http://schemas.openxmlformats.org/drawingml/2006/main" l="26000" t="16500" r="26000" b="44000"/>
           <a:stretch xmlns:a="http://schemas.openxmlformats.org/drawingml/2006/main"/>
         </p:blipFill>
@@ -14741,7 +14741,7 @@
           <p:cNvPr id="106" name="review-label-0">
             <a:extLst xmlns:a="http://schemas.openxmlformats.org/drawingml/2006/main">
               <a:ext uri="{FF2B5EF4-FFF2-40B4-BE49-F238E27FC236}">
-                <a16:creationId xmlns:a16="http://schemas.microsoft.com/office/drawing/2014/main" id="{F4DAA970-54FC-41BF-A233-577B796654AC}"/>
+                <a16:creationId xmlns:a16="http://schemas.microsoft.com/office/drawing/2014/main" id="{8BC19B58-9D5F-4906-B336-4E76F2DA85CB}"/>
               </a:ext>
             </a:extLst>
           </p:cNvPr>
@@ -14809,7 +14809,7 @@
           <p:cNvPr id="107" name="review-body-0">
             <a:extLst xmlns:a="http://schemas.openxmlformats.org/drawingml/2006/main">
               <a:ext uri="{FF2B5EF4-FFF2-40B4-BE49-F238E27FC236}">
-                <a16:creationId xmlns:a16="http://schemas.microsoft.com/office/drawing/2014/main" id="{4F79DFC4-5BBC-4DA2-A4C1-7E42BECA96FD}"/>
+                <a16:creationId xmlns:a16="http://schemas.microsoft.com/office/drawing/2014/main" id="{86A83AEC-5725-4D68-ACE4-86BD74F94E32}"/>
               </a:ext>
             </a:extLst>
           </p:cNvPr>
@@ -14900,7 +14900,7 @@
           <p:cNvPr id="108" name="review-label-1">
             <a:extLst xmlns:a="http://schemas.openxmlformats.org/drawingml/2006/main">
               <a:ext uri="{FF2B5EF4-FFF2-40B4-BE49-F238E27FC236}">
-                <a16:creationId xmlns:a16="http://schemas.microsoft.com/office/drawing/2014/main" id="{D7F15BA1-2D26-4986-A580-6C557F453FEF}"/>
+                <a16:creationId xmlns:a16="http://schemas.microsoft.com/office/drawing/2014/main" id="{919409A5-27C5-47FE-82BC-11C4F55C846A}"/>
               </a:ext>
             </a:extLst>
           </p:cNvPr>
@@ -14968,7 +14968,7 @@
           <p:cNvPr id="109" name="review-body-1">
             <a:extLst xmlns:a="http://schemas.openxmlformats.org/drawingml/2006/main">
               <a:ext uri="{FF2B5EF4-FFF2-40B4-BE49-F238E27FC236}">
-                <a16:creationId xmlns:a16="http://schemas.microsoft.com/office/drawing/2014/main" id="{C7DE8CC3-6B7E-4E60-8457-CD46643B945F}"/>
+                <a16:creationId xmlns:a16="http://schemas.microsoft.com/office/drawing/2014/main" id="{A2E0D09E-ED70-4686-94F6-748884905048}"/>
               </a:ext>
             </a:extLst>
           </p:cNvPr>
@@ -15059,7 +15059,7 @@
           <p:cNvPr id="110" name="review-label-2">
             <a:extLst xmlns:a="http://schemas.openxmlformats.org/drawingml/2006/main">
               <a:ext uri="{FF2B5EF4-FFF2-40B4-BE49-F238E27FC236}">
-                <a16:creationId xmlns:a16="http://schemas.microsoft.com/office/drawing/2014/main" id="{7FD3478F-19FA-402F-A984-02824865ED79}"/>
+                <a16:creationId xmlns:a16="http://schemas.microsoft.com/office/drawing/2014/main" id="{3CC4F5BE-1411-4869-ABF2-F44C8735A5F1}"/>
               </a:ext>
             </a:extLst>
           </p:cNvPr>
@@ -15127,7 +15127,7 @@
           <p:cNvPr id="111" name="review-body-2">
             <a:extLst xmlns:a="http://schemas.openxmlformats.org/drawingml/2006/main">
               <a:ext uri="{FF2B5EF4-FFF2-40B4-BE49-F238E27FC236}">
-                <a16:creationId xmlns:a16="http://schemas.microsoft.com/office/drawing/2014/main" id="{DA0A752C-7E84-4630-A84A-EB8EDD024C8D}"/>
+                <a16:creationId xmlns:a16="http://schemas.microsoft.com/office/drawing/2014/main" id="{8FED6FAA-F19D-4CD7-9F14-604B81AC6151}"/>
               </a:ext>
             </a:extLst>
           </p:cNvPr>
@@ -15218,7 +15218,7 @@
           <p:cNvPr id="112" name="review-foot">
             <a:extLst xmlns:a="http://schemas.openxmlformats.org/drawingml/2006/main">
               <a:ext uri="{FF2B5EF4-FFF2-40B4-BE49-F238E27FC236}">
-                <a16:creationId xmlns:a16="http://schemas.microsoft.com/office/drawing/2014/main" id="{C529C94F-6BED-44FF-BF65-EB7E873CE3FD}"/>
+                <a16:creationId xmlns:a16="http://schemas.microsoft.com/office/drawing/2014/main" id="{83554E10-E669-413A-B4CA-D07255F9E1C7}"/>
               </a:ext>
             </a:extLst>
           </p:cNvPr>
@@ -15284,7 +15284,7 @@
     </p:spTree>
     <p:extLst>
       <p:ext uri="{BB962C8B-B14F-4D97-AF65-F5344CB8AC3E}">
-        <p14:creationId xmlns:p14="http://schemas.microsoft.com/office/powerpoint/2010/main" val="225028422"/>
+        <p14:creationId xmlns:p14="http://schemas.microsoft.com/office/powerpoint/2010/main" val="1321765859"/>
       </p:ext>
     </p:extLst>
   </p:cSld>
@@ -15308,7 +15308,7 @@
           <p:cNvPr id="127" name="">
             <a:extLst xmlns:a="http://schemas.openxmlformats.org/drawingml/2006/main">
               <a:ext uri="{FF2B5EF4-FFF2-40B4-BE49-F238E27FC236}">
-                <a16:creationId xmlns:a16="http://schemas.microsoft.com/office/drawing/2014/main" id="{C6A634FC-7E76-4E99-B5C2-5FF4E5AAC4FD}"/>
+                <a16:creationId xmlns:a16="http://schemas.microsoft.com/office/drawing/2014/main" id="{C9871425-7799-4078-8BD3-DBBC3630A1CF}"/>
               </a:ext>
             </a:extLst>
           </p:cNvPr>
@@ -15339,7 +15339,7 @@
           <p:cNvPr id="126" name="">
             <a:extLst xmlns:a="http://schemas.openxmlformats.org/drawingml/2006/main">
               <a:ext uri="{FF2B5EF4-FFF2-40B4-BE49-F238E27FC236}">
-                <a16:creationId xmlns:a16="http://schemas.microsoft.com/office/drawing/2014/main" id="{D800B2C2-9394-4C4B-8EA3-6CEC3955713D}"/>
+                <a16:creationId xmlns:a16="http://schemas.microsoft.com/office/drawing/2014/main" id="{28EEA1D1-7970-44D1-A2FC-4F92F9335B10}"/>
               </a:ext>
             </a:extLst>
           </p:cNvPr>
@@ -15370,7 +15370,7 @@
           <p:cNvPr id="125" name="">
             <a:extLst xmlns:a="http://schemas.openxmlformats.org/drawingml/2006/main">
               <a:ext uri="{FF2B5EF4-FFF2-40B4-BE49-F238E27FC236}">
-                <a16:creationId xmlns:a16="http://schemas.microsoft.com/office/drawing/2014/main" id="{B841E651-7E25-4A95-9FB0-36583104142A}"/>
+                <a16:creationId xmlns:a16="http://schemas.microsoft.com/office/drawing/2014/main" id="{6134EE9B-358A-48A0-92D2-C1B415E11F29}"/>
               </a:ext>
             </a:extLst>
           </p:cNvPr>
@@ -15403,7 +15403,7 @@
           <p:cNvPr id="124" name="">
             <a:extLst xmlns:a="http://schemas.openxmlformats.org/drawingml/2006/main">
               <a:ext uri="{FF2B5EF4-FFF2-40B4-BE49-F238E27FC236}">
-                <a16:creationId xmlns:a16="http://schemas.microsoft.com/office/drawing/2014/main" id="{5D7CC041-A976-43A2-868A-B5B6B298CFF3}"/>
+                <a16:creationId xmlns:a16="http://schemas.microsoft.com/office/drawing/2014/main" id="{12033D3D-8C34-4870-AAAC-8B0C11DD35D7}"/>
               </a:ext>
             </a:extLst>
           </p:cNvPr>
@@ -15434,7 +15434,7 @@
           <p:cNvPr id="123" name="">
             <a:extLst xmlns:a="http://schemas.openxmlformats.org/drawingml/2006/main">
               <a:ext uri="{FF2B5EF4-FFF2-40B4-BE49-F238E27FC236}">
-                <a16:creationId xmlns:a16="http://schemas.microsoft.com/office/drawing/2014/main" id="{62BB4077-6B7A-4A68-AAF2-8158618F04E4}"/>
+                <a16:creationId xmlns:a16="http://schemas.microsoft.com/office/drawing/2014/main" id="{9BC2CAB3-DBD7-4286-ABA4-4D7DC28136A6}"/>
               </a:ext>
             </a:extLst>
           </p:cNvPr>
@@ -15465,7 +15465,7 @@
           <p:cNvPr id="122" name="">
             <a:extLst xmlns:a="http://schemas.openxmlformats.org/drawingml/2006/main">
               <a:ext uri="{FF2B5EF4-FFF2-40B4-BE49-F238E27FC236}">
-                <a16:creationId xmlns:a16="http://schemas.microsoft.com/office/drawing/2014/main" id="{C206BFFE-74F3-4453-9768-055985A36089}"/>
+                <a16:creationId xmlns:a16="http://schemas.microsoft.com/office/drawing/2014/main" id="{9E1B2ED1-F7FF-45FA-BBF7-445F6D269CE7}"/>
               </a:ext>
             </a:extLst>
           </p:cNvPr>
@@ -15497,7 +15497,7 @@
           <p:cNvPr id="121" name="">
             <a:extLst xmlns:a="http://schemas.openxmlformats.org/drawingml/2006/main">
               <a:ext uri="{FF2B5EF4-FFF2-40B4-BE49-F238E27FC236}">
-                <a16:creationId xmlns:a16="http://schemas.microsoft.com/office/drawing/2014/main" id="{190BCB39-91EA-42FC-92D7-80C4207AE83B}"/>
+                <a16:creationId xmlns:a16="http://schemas.microsoft.com/office/drawing/2014/main" id="{C20AFE1A-8926-4DDE-BB69-70D02648BDF9}"/>
               </a:ext>
             </a:extLst>
           </p:cNvPr>
@@ -15530,7 +15530,7 @@
           <p:cNvPr id="108" name="Google Shape;108;p20">
             <a:extLst xmlns:a="http://schemas.openxmlformats.org/drawingml/2006/main">
               <a:ext uri="{FF2B5EF4-FFF2-40B4-BE49-F238E27FC236}">
-                <a16:creationId xmlns:a16="http://schemas.microsoft.com/office/drawing/2014/main" id="{A9AF2ECC-3F5C-439A-B4C7-E968DC802782}"/>
+                <a16:creationId xmlns:a16="http://schemas.microsoft.com/office/drawing/2014/main" id="{4E1F2F40-52A8-4D99-9D4B-A9B0298869D7}"/>
               </a:ext>
             </a:extLst>
           </p:cNvPr>
@@ -15540,7 +15540,7 @@
           <p:nvPr/>
         </p:nvPicPr>
         <p:blipFill rotWithShape="1">
-          <a:blip xmlns:r="http://schemas.openxmlformats.org/officeDocument/2006/relationships" xmlns:a="http://schemas.openxmlformats.org/drawingml/2006/main" r:embed="Rb954f2294a0346b4">
+          <a:blip xmlns:r="http://schemas.openxmlformats.org/officeDocument/2006/relationships" xmlns:a="http://schemas.openxmlformats.org/drawingml/2006/main" r:embed="R484a955e565e4ffa">
             <a:alphaModFix/>
           </a:blip>
           <a:srcRect xmlns:a="http://schemas.openxmlformats.org/drawingml/2006/main" l="0" t="0" r="0" b="98001"/>
@@ -15564,7 +15564,7 @@
           <p:cNvPr id="109" name="Google Shape;109;p20">
             <a:extLst xmlns:a="http://schemas.openxmlformats.org/drawingml/2006/main">
               <a:ext uri="{FF2B5EF4-FFF2-40B4-BE49-F238E27FC236}">
-                <a16:creationId xmlns:a16="http://schemas.microsoft.com/office/drawing/2014/main" id="{DE5A864E-D1FB-46AD-9F5B-D093F5C6ED97}"/>
+                <a16:creationId xmlns:a16="http://schemas.microsoft.com/office/drawing/2014/main" id="{8A1687CF-7216-43E4-A95E-46975A76F4F6}"/>
               </a:ext>
             </a:extLst>
           </p:cNvPr>
@@ -15574,7 +15574,7 @@
           <p:nvPr/>
         </p:nvPicPr>
         <p:blipFill>
-          <a:blip xmlns:r="http://schemas.openxmlformats.org/officeDocument/2006/relationships" xmlns:a="http://schemas.openxmlformats.org/drawingml/2006/main" r:embed="R91291e4263054d84">
+          <a:blip xmlns:r="http://schemas.openxmlformats.org/officeDocument/2006/relationships" xmlns:a="http://schemas.openxmlformats.org/drawingml/2006/main" r:embed="R6d94bc85db824048">
             <a:alphaModFix/>
           </a:blip>
           <a:stretch xmlns:a="http://schemas.openxmlformats.org/drawingml/2006/main">
@@ -15599,7 +15599,7 @@
           <p:cNvPr id="110" name="Google Shape;110;p20">
             <a:extLst xmlns:a="http://schemas.openxmlformats.org/drawingml/2006/main">
               <a:ext uri="{FF2B5EF4-FFF2-40B4-BE49-F238E27FC236}">
-                <a16:creationId xmlns:a16="http://schemas.microsoft.com/office/drawing/2014/main" id="{85377A13-0417-4C24-855F-4D01F36547C4}"/>
+                <a16:creationId xmlns:a16="http://schemas.microsoft.com/office/drawing/2014/main" id="{040E3987-7A30-4A4C-87F7-E4D9967497AA}"/>
               </a:ext>
             </a:extLst>
           </p:cNvPr>
@@ -15650,7 +15650,7 @@
           <p:cNvPr id="111" name="Google Shape;111;p20">
             <a:extLst xmlns:a="http://schemas.openxmlformats.org/drawingml/2006/main">
               <a:ext uri="{FF2B5EF4-FFF2-40B4-BE49-F238E27FC236}">
-                <a16:creationId xmlns:a16="http://schemas.microsoft.com/office/drawing/2014/main" id="{44737E70-ABB7-4EC5-81D4-D6116D25DD7A}"/>
+                <a16:creationId xmlns:a16="http://schemas.microsoft.com/office/drawing/2014/main" id="{4756C42D-1D43-49AD-9A96-ADCDA3181397}"/>
               </a:ext>
             </a:extLst>
           </p:cNvPr>
@@ -15730,7 +15730,7 @@
           <p:cNvPr id="112" name="architecture-ui">
             <a:extLst xmlns:a="http://schemas.openxmlformats.org/drawingml/2006/main">
               <a:ext uri="{FF2B5EF4-FFF2-40B4-BE49-F238E27FC236}">
-                <a16:creationId xmlns:a16="http://schemas.microsoft.com/office/drawing/2014/main" id="{05F89A10-8C54-4204-B032-66DC9506FBC6}"/>
+                <a16:creationId xmlns:a16="http://schemas.microsoft.com/office/drawing/2014/main" id="{4130A0CF-349A-4BE0-8AE1-4D52AE948BC8}"/>
               </a:ext>
             </a:extLst>
           </p:cNvPr>
@@ -15825,7 +15825,7 @@
           <p:cNvPr id="113" name="architecture-model">
             <a:extLst xmlns:a="http://schemas.openxmlformats.org/drawingml/2006/main">
               <a:ext uri="{FF2B5EF4-FFF2-40B4-BE49-F238E27FC236}">
-                <a16:creationId xmlns:a16="http://schemas.microsoft.com/office/drawing/2014/main" id="{4ED182A1-7B37-4105-A88F-03547BF31D4F}"/>
+                <a16:creationId xmlns:a16="http://schemas.microsoft.com/office/drawing/2014/main" id="{BB4AAF93-23F3-4F20-8DE2-B9E3D03E9737}"/>
               </a:ext>
             </a:extLst>
           </p:cNvPr>
@@ -15920,7 +15920,7 @@
           <p:cNvPr id="114" name="model-boundary">
             <a:extLst xmlns:a="http://schemas.openxmlformats.org/drawingml/2006/main">
               <a:ext uri="{FF2B5EF4-FFF2-40B4-BE49-F238E27FC236}">
-                <a16:creationId xmlns:a16="http://schemas.microsoft.com/office/drawing/2014/main" id="{BA5AF30B-DEC1-405B-A701-CF0856779C66}"/>
+                <a16:creationId xmlns:a16="http://schemas.microsoft.com/office/drawing/2014/main" id="{02D2BFB5-E579-46FA-AC48-CDC650A59E6D}"/>
               </a:ext>
             </a:extLst>
           </p:cNvPr>
@@ -16011,7 +16011,7 @@
           <p:cNvPr id="115" name="Cloud Run runtime boundary">
             <a:extLst xmlns:a="http://schemas.openxmlformats.org/drawingml/2006/main">
               <a:ext uri="{FF2B5EF4-FFF2-40B4-BE49-F238E27FC236}">
-                <a16:creationId xmlns:a16="http://schemas.microsoft.com/office/drawing/2014/main" id="{E2DB131C-27B2-4004-AE7E-118F319724EE}"/>
+                <a16:creationId xmlns:a16="http://schemas.microsoft.com/office/drawing/2014/main" id="{765A9984-8B23-4E31-A436-D39B0945EF7A}"/>
               </a:ext>
             </a:extLst>
           </p:cNvPr>
@@ -16041,7 +16041,7 @@
           <p:cNvPr id="116" name="cloud-run-label">
             <a:extLst xmlns:a="http://schemas.openxmlformats.org/drawingml/2006/main">
               <a:ext uri="{FF2B5EF4-FFF2-40B4-BE49-F238E27FC236}">
-                <a16:creationId xmlns:a16="http://schemas.microsoft.com/office/drawing/2014/main" id="{7B5E60D0-D405-4E7F-AFF3-6E589F88C01C}"/>
+                <a16:creationId xmlns:a16="http://schemas.microsoft.com/office/drawing/2014/main" id="{C1F84D6F-10BA-40FD-AF98-75E12AC2A01F}"/>
               </a:ext>
             </a:extLst>
           </p:cNvPr>
@@ -16109,7 +16109,7 @@
           <p:cNvPr id="117" name="architecture-metro">
             <a:extLst xmlns:a="http://schemas.openxmlformats.org/drawingml/2006/main">
               <a:ext uri="{FF2B5EF4-FFF2-40B4-BE49-F238E27FC236}">
-                <a16:creationId xmlns:a16="http://schemas.microsoft.com/office/drawing/2014/main" id="{088D0541-ABB7-4CF8-BF83-AB4F6E2A30BB}"/>
+                <a16:creationId xmlns:a16="http://schemas.microsoft.com/office/drawing/2014/main" id="{10EEC637-4331-4254-8DC3-A7C454996E60}"/>
               </a:ext>
             </a:extLst>
           </p:cNvPr>
@@ -16204,7 +16204,7 @@
           <p:cNvPr id="118" name="architecture-api">
             <a:extLst xmlns:a="http://schemas.openxmlformats.org/drawingml/2006/main">
               <a:ext uri="{FF2B5EF4-FFF2-40B4-BE49-F238E27FC236}">
-                <a16:creationId xmlns:a16="http://schemas.microsoft.com/office/drawing/2014/main" id="{1217DC34-3BDE-4047-A6A1-BAEEBFDE2189}"/>
+                <a16:creationId xmlns:a16="http://schemas.microsoft.com/office/drawing/2014/main" id="{0B561405-4C19-47E3-A542-4D9A95FF5E83}"/>
               </a:ext>
             </a:extLst>
           </p:cNvPr>
@@ -16299,7 +16299,7 @@
           <p:cNvPr id="119" name="architecture-twin">
             <a:extLst xmlns:a="http://schemas.openxmlformats.org/drawingml/2006/main">
               <a:ext uri="{FF2B5EF4-FFF2-40B4-BE49-F238E27FC236}">
-                <a16:creationId xmlns:a16="http://schemas.microsoft.com/office/drawing/2014/main" id="{9F75AB54-3057-4DA3-83C0-E8C69BB94D9A}"/>
+                <a16:creationId xmlns:a16="http://schemas.microsoft.com/office/drawing/2014/main" id="{361C5C2A-ED6E-4F29-A1FF-6127D30B41E3}"/>
               </a:ext>
             </a:extLst>
           </p:cNvPr>
@@ -16394,7 +16394,7 @@
           <p:cNvPr id="120" name="architecture-gate">
             <a:extLst xmlns:a="http://schemas.openxmlformats.org/drawingml/2006/main">
               <a:ext uri="{FF2B5EF4-FFF2-40B4-BE49-F238E27FC236}">
-                <a16:creationId xmlns:a16="http://schemas.microsoft.com/office/drawing/2014/main" id="{765A59A2-291D-49C5-8C38-A19577AE87CF}"/>
+                <a16:creationId xmlns:a16="http://schemas.microsoft.com/office/drawing/2014/main" id="{3D688EFF-A5EC-4925-ADAF-99FF73CEB5CD}"/>
               </a:ext>
             </a:extLst>
           </p:cNvPr>
@@ -16489,7 +16489,7 @@
           <p:cNvPr id="128" name="architecture-observe">
             <a:extLst xmlns:a="http://schemas.openxmlformats.org/drawingml/2006/main">
               <a:ext uri="{FF2B5EF4-FFF2-40B4-BE49-F238E27FC236}">
-                <a16:creationId xmlns:a16="http://schemas.microsoft.com/office/drawing/2014/main" id="{10CCBC14-A5DD-40C8-8645-55A1CFF2490F}"/>
+                <a16:creationId xmlns:a16="http://schemas.microsoft.com/office/drawing/2014/main" id="{465A0190-A7F3-467C-89C7-0252D75925F2}"/>
               </a:ext>
             </a:extLst>
           </p:cNvPr>
@@ -16557,7 +16557,7 @@
           <p:cNvPr id="129" name="architecture-test">
             <a:extLst xmlns:a="http://schemas.openxmlformats.org/drawingml/2006/main">
               <a:ext uri="{FF2B5EF4-FFF2-40B4-BE49-F238E27FC236}">
-                <a16:creationId xmlns:a16="http://schemas.microsoft.com/office/drawing/2014/main" id="{7574E392-9A7B-4411-9BDE-284C5A6BC7AA}"/>
+                <a16:creationId xmlns:a16="http://schemas.microsoft.com/office/drawing/2014/main" id="{75F6E447-E9AD-41CC-B4B7-DFBA6DA3847E}"/>
               </a:ext>
             </a:extLst>
           </p:cNvPr>
@@ -16625,7 +16625,7 @@
           <p:cNvPr id="130" name="architecture-results">
             <a:extLst xmlns:a="http://schemas.openxmlformats.org/drawingml/2006/main">
               <a:ext uri="{FF2B5EF4-FFF2-40B4-BE49-F238E27FC236}">
-                <a16:creationId xmlns:a16="http://schemas.microsoft.com/office/drawing/2014/main" id="{6AB05749-85FA-46B0-A19F-E96CA7FAB7E3}"/>
+                <a16:creationId xmlns:a16="http://schemas.microsoft.com/office/drawing/2014/main" id="{4716177F-37D3-45A4-B193-78A54A551BEC}"/>
               </a:ext>
             </a:extLst>
           </p:cNvPr>
@@ -16693,7 +16693,7 @@
           <p:cNvPr id="131" name="architecture-write">
             <a:extLst xmlns:a="http://schemas.openxmlformats.org/drawingml/2006/main">
               <a:ext uri="{FF2B5EF4-FFF2-40B4-BE49-F238E27FC236}">
-                <a16:creationId xmlns:a16="http://schemas.microsoft.com/office/drawing/2014/main" id="{92167318-67A7-4437-B864-96F6F623DFF5}"/>
+                <a16:creationId xmlns:a16="http://schemas.microsoft.com/office/drawing/2014/main" id="{E2CCB116-33A0-4B92-B42D-64F3A4B3503B}"/>
               </a:ext>
             </a:extLst>
           </p:cNvPr>
@@ -16761,7 +16761,7 @@
           <p:cNvPr id="132" name="architecture-footer">
             <a:extLst xmlns:a="http://schemas.openxmlformats.org/drawingml/2006/main">
               <a:ext uri="{FF2B5EF4-FFF2-40B4-BE49-F238E27FC236}">
-                <a16:creationId xmlns:a16="http://schemas.microsoft.com/office/drawing/2014/main" id="{5B2F9FDB-B658-45CF-8C58-DCA18D4D26D6}"/>
+                <a16:creationId xmlns:a16="http://schemas.microsoft.com/office/drawing/2014/main" id="{1EEB0A81-41F5-45E3-B32D-CD5F5D32AC88}"/>
               </a:ext>
             </a:extLst>
           </p:cNvPr>
@@ -16850,7 +16850,7 @@
     </p:spTree>
     <p:extLst>
       <p:ext uri="{BB962C8B-B14F-4D97-AF65-F5344CB8AC3E}">
-        <p14:creationId xmlns:p14="http://schemas.microsoft.com/office/powerpoint/2010/main" val="351905455"/>
+        <p14:creationId xmlns:p14="http://schemas.microsoft.com/office/powerpoint/2010/main" val="536673712"/>
       </p:ext>
     </p:extLst>
   </p:cSld>
@@ -16874,7 +16874,7 @@
           <p:cNvPr id="116" name="Google Shape;116;p21">
             <a:extLst xmlns:a="http://schemas.openxmlformats.org/drawingml/2006/main">
               <a:ext uri="{FF2B5EF4-FFF2-40B4-BE49-F238E27FC236}">
-                <a16:creationId xmlns:a16="http://schemas.microsoft.com/office/drawing/2014/main" id="{B6DCFCD5-313E-4980-8EC1-91B11B7B9554}"/>
+                <a16:creationId xmlns:a16="http://schemas.microsoft.com/office/drawing/2014/main" id="{926184FF-55B2-4BDC-953A-67E647D9BBBE}"/>
               </a:ext>
             </a:extLst>
           </p:cNvPr>
@@ -16884,7 +16884,7 @@
           <p:nvPr/>
         </p:nvPicPr>
         <p:blipFill rotWithShape="1">
-          <a:blip xmlns:r="http://schemas.openxmlformats.org/officeDocument/2006/relationships" xmlns:a="http://schemas.openxmlformats.org/drawingml/2006/main" r:embed="Rcdb538bf88af4fdf">
+          <a:blip xmlns:r="http://schemas.openxmlformats.org/officeDocument/2006/relationships" xmlns:a="http://schemas.openxmlformats.org/drawingml/2006/main" r:embed="R5dda6ddc0285423b">
             <a:alphaModFix/>
           </a:blip>
           <a:srcRect xmlns:a="http://schemas.openxmlformats.org/drawingml/2006/main" l="0" t="0" r="0" b="98001"/>
@@ -16908,7 +16908,7 @@
           <p:cNvPr id="117" name="Google Shape;117;p21">
             <a:extLst xmlns:a="http://schemas.openxmlformats.org/drawingml/2006/main">
               <a:ext uri="{FF2B5EF4-FFF2-40B4-BE49-F238E27FC236}">
-                <a16:creationId xmlns:a16="http://schemas.microsoft.com/office/drawing/2014/main" id="{EDB6581A-4B8D-4A87-9834-94A19EFE5FB7}"/>
+                <a16:creationId xmlns:a16="http://schemas.microsoft.com/office/drawing/2014/main" id="{AD0E3C0F-0237-46C8-9ABB-EFC18A504F24}"/>
               </a:ext>
             </a:extLst>
           </p:cNvPr>
@@ -16918,7 +16918,7 @@
           <p:nvPr/>
         </p:nvPicPr>
         <p:blipFill>
-          <a:blip xmlns:r="http://schemas.openxmlformats.org/officeDocument/2006/relationships" xmlns:a="http://schemas.openxmlformats.org/drawingml/2006/main" r:embed="Rad402c1ff0024259">
+          <a:blip xmlns:r="http://schemas.openxmlformats.org/officeDocument/2006/relationships" xmlns:a="http://schemas.openxmlformats.org/drawingml/2006/main" r:embed="R7f2882a0e04d446c">
             <a:alphaModFix/>
           </a:blip>
           <a:stretch xmlns:a="http://schemas.openxmlformats.org/drawingml/2006/main">
@@ -16943,7 +16943,7 @@
           <p:cNvPr id="118" name="Google Shape;118;p21">
             <a:extLst xmlns:a="http://schemas.openxmlformats.org/drawingml/2006/main">
               <a:ext uri="{FF2B5EF4-FFF2-40B4-BE49-F238E27FC236}">
-                <a16:creationId xmlns:a16="http://schemas.microsoft.com/office/drawing/2014/main" id="{4C745EC5-13A2-4514-ABB0-C5C98A1146E0}"/>
+                <a16:creationId xmlns:a16="http://schemas.microsoft.com/office/drawing/2014/main" id="{7C2503AC-B347-42D2-AD81-9714628E2168}"/>
               </a:ext>
             </a:extLst>
           </p:cNvPr>
@@ -16994,7 +16994,7 @@
           <p:cNvPr id="119" name="Google Shape;119;p21">
             <a:extLst xmlns:a="http://schemas.openxmlformats.org/drawingml/2006/main">
               <a:ext uri="{FF2B5EF4-FFF2-40B4-BE49-F238E27FC236}">
-                <a16:creationId xmlns:a16="http://schemas.microsoft.com/office/drawing/2014/main" id="{A276EA9A-A38B-4022-BACF-9F08E346B721}"/>
+                <a16:creationId xmlns:a16="http://schemas.microsoft.com/office/drawing/2014/main" id="{4D16E690-80CA-4325-A2B0-DF7992FDA837}"/>
               </a:ext>
             </a:extLst>
           </p:cNvPr>
@@ -17074,7 +17074,7 @@
           <p:cNvPr id="120" name="">
             <a:extLst xmlns:a="http://schemas.openxmlformats.org/drawingml/2006/main">
               <a:ext uri="{FF2B5EF4-FFF2-40B4-BE49-F238E27FC236}">
-                <a16:creationId xmlns:a16="http://schemas.microsoft.com/office/drawing/2014/main" id="{1796A665-720E-4897-B7C8-AD25E60EE0B0}"/>
+                <a16:creationId xmlns:a16="http://schemas.microsoft.com/office/drawing/2014/main" id="{F5F20C1E-7216-4587-B39D-EE6A6909FF3D}"/>
               </a:ext>
             </a:extLst>
           </p:cNvPr>
@@ -17502,7 +17502,7 @@
                           <a:ea typeface="Google Sans Flex"/>
                           <a:cs typeface="Google Sans Flex"/>
                         </a:rPr>
-                        <a:t>Provides the private operator approval credential</a:t>
+                        <a:t>Stores the server credential for protected approval mode</a:t>
                       </a:r>
                     </a:p>
                   </a:txBody>
@@ -17786,7 +17786,7 @@
           <p:cNvPr id="121" name="tech-scope">
             <a:extLst xmlns:a="http://schemas.openxmlformats.org/drawingml/2006/main">
               <a:ext uri="{FF2B5EF4-FFF2-40B4-BE49-F238E27FC236}">
-                <a16:creationId xmlns:a16="http://schemas.microsoft.com/office/drawing/2014/main" id="{DA9EF77F-A5EB-4236-9730-E93FAAE6F939}"/>
+                <a16:creationId xmlns:a16="http://schemas.microsoft.com/office/drawing/2014/main" id="{432D3163-636A-41D2-9D21-016E161F7B4C}"/>
               </a:ext>
             </a:extLst>
           </p:cNvPr>
@@ -17852,7 +17852,7 @@
     </p:spTree>
     <p:extLst>
       <p:ext uri="{BB962C8B-B14F-4D97-AF65-F5344CB8AC3E}">
-        <p14:creationId xmlns:p14="http://schemas.microsoft.com/office/powerpoint/2010/main" val="4471603"/>
+        <p14:creationId xmlns:p14="http://schemas.microsoft.com/office/powerpoint/2010/main" val="1826510714"/>
       </p:ext>
     </p:extLst>
   </p:cSld>
@@ -17876,7 +17876,7 @@
           <p:cNvPr id="132" name="Google Shape;132;p23">
             <a:extLst xmlns:a="http://schemas.openxmlformats.org/drawingml/2006/main">
               <a:ext uri="{FF2B5EF4-FFF2-40B4-BE49-F238E27FC236}">
-                <a16:creationId xmlns:a16="http://schemas.microsoft.com/office/drawing/2014/main" id="{7EF58C41-D508-4E71-95D0-6198DAA6C997}"/>
+                <a16:creationId xmlns:a16="http://schemas.microsoft.com/office/drawing/2014/main" id="{29DA9207-F625-422E-B91E-ADC3451BC450}"/>
               </a:ext>
             </a:extLst>
           </p:cNvPr>
@@ -17886,7 +17886,7 @@
           <p:nvPr/>
         </p:nvPicPr>
         <p:blipFill rotWithShape="1">
-          <a:blip xmlns:r="http://schemas.openxmlformats.org/officeDocument/2006/relationships" xmlns:a="http://schemas.openxmlformats.org/drawingml/2006/main" r:embed="R6181098298d04fa6">
+          <a:blip xmlns:r="http://schemas.openxmlformats.org/officeDocument/2006/relationships" xmlns:a="http://schemas.openxmlformats.org/drawingml/2006/main" r:embed="R9ca41cc13515471f">
             <a:alphaModFix/>
           </a:blip>
           <a:srcRect xmlns:a="http://schemas.openxmlformats.org/drawingml/2006/main" l="0" t="0" r="0" b="98001"/>
@@ -17910,7 +17910,7 @@
           <p:cNvPr id="133" name="Google Shape;133;p23">
             <a:extLst xmlns:a="http://schemas.openxmlformats.org/drawingml/2006/main">
               <a:ext uri="{FF2B5EF4-FFF2-40B4-BE49-F238E27FC236}">
-                <a16:creationId xmlns:a16="http://schemas.microsoft.com/office/drawing/2014/main" id="{CB3FA706-81C6-487A-B926-B494770C01BB}"/>
+                <a16:creationId xmlns:a16="http://schemas.microsoft.com/office/drawing/2014/main" id="{1C43F92F-71F5-454C-8465-020466B28022}"/>
               </a:ext>
             </a:extLst>
           </p:cNvPr>
@@ -17920,7 +17920,7 @@
           <p:nvPr/>
         </p:nvPicPr>
         <p:blipFill>
-          <a:blip xmlns:r="http://schemas.openxmlformats.org/officeDocument/2006/relationships" xmlns:a="http://schemas.openxmlformats.org/drawingml/2006/main" r:embed="R1aca3bb622794140">
+          <a:blip xmlns:r="http://schemas.openxmlformats.org/officeDocument/2006/relationships" xmlns:a="http://schemas.openxmlformats.org/drawingml/2006/main" r:embed="R2d0489f4cda945ce">
             <a:alphaModFix/>
           </a:blip>
           <a:stretch xmlns:a="http://schemas.openxmlformats.org/drawingml/2006/main">
@@ -17945,7 +17945,7 @@
           <p:cNvPr id="134" name="Google Shape;134;p23">
             <a:extLst xmlns:a="http://schemas.openxmlformats.org/drawingml/2006/main">
               <a:ext uri="{FF2B5EF4-FFF2-40B4-BE49-F238E27FC236}">
-                <a16:creationId xmlns:a16="http://schemas.microsoft.com/office/drawing/2014/main" id="{D0A7B225-F84D-4F78-AEF8-B892596234A7}"/>
+                <a16:creationId xmlns:a16="http://schemas.microsoft.com/office/drawing/2014/main" id="{C565F400-EE6A-4090-9E4F-07C6E8E061D2}"/>
               </a:ext>
             </a:extLst>
           </p:cNvPr>
@@ -17996,7 +17996,7 @@
           <p:cNvPr id="135" name="Google Shape;135;p23">
             <a:extLst xmlns:a="http://schemas.openxmlformats.org/drawingml/2006/main">
               <a:ext uri="{FF2B5EF4-FFF2-40B4-BE49-F238E27FC236}">
-                <a16:creationId xmlns:a16="http://schemas.microsoft.com/office/drawing/2014/main" id="{5F7C5680-73C5-41CB-8EB0-F3A11AB6289C}"/>
+                <a16:creationId xmlns:a16="http://schemas.microsoft.com/office/drawing/2014/main" id="{810A699A-A0B5-407D-9C25-0F421DF4FB31}"/>
               </a:ext>
             </a:extLst>
           </p:cNvPr>
@@ -18076,7 +18076,7 @@
           <p:cNvPr id="136" name="recovery-headline">
             <a:extLst xmlns:a="http://schemas.openxmlformats.org/drawingml/2006/main">
               <a:ext uri="{FF2B5EF4-FFF2-40B4-BE49-F238E27FC236}">
-                <a16:creationId xmlns:a16="http://schemas.microsoft.com/office/drawing/2014/main" id="{258E04F3-76D0-410A-9E8A-D3222DB2BF89}"/>
+                <a16:creationId xmlns:a16="http://schemas.microsoft.com/office/drawing/2014/main" id="{AD3BAED0-190B-4DD1-9EF4-34BDB60AEE19}"/>
               </a:ext>
             </a:extLst>
           </p:cNvPr>
@@ -18144,7 +18144,7 @@
           <p:cNvPr id="137" name="">
             <a:extLst xmlns:a="http://schemas.openxmlformats.org/drawingml/2006/main">
               <a:ext uri="{FF2B5EF4-FFF2-40B4-BE49-F238E27FC236}">
-                <a16:creationId xmlns:a16="http://schemas.microsoft.com/office/drawing/2014/main" id="{B1E41AD5-173C-4705-B017-72FAB246BD0D}"/>
+                <a16:creationId xmlns:a16="http://schemas.microsoft.com/office/drawing/2014/main" id="{229AFD0C-A93B-4260-B8C2-9EFB68A2DFB6}"/>
               </a:ext>
             </a:extLst>
           </p:cNvPr>
@@ -18154,7 +18154,7 @@
           <p:nvPr/>
         </p:nvPicPr>
         <p:blipFill>
-          <a:blip xmlns:r="http://schemas.openxmlformats.org/officeDocument/2006/relationships" xmlns:a="http://schemas.openxmlformats.org/drawingml/2006/main" r:embed="R19ccabfbfac9470e"/>
+          <a:blip xmlns:r="http://schemas.openxmlformats.org/officeDocument/2006/relationships" xmlns:a="http://schemas.openxmlformats.org/drawingml/2006/main" r:embed="Re6bfd4ebe08f4345"/>
           <a:srcRect xmlns:a="http://schemas.openxmlformats.org/drawingml/2006/main" l="19500" t="29800" r="19500" b="28200"/>
           <a:stretch xmlns:a="http://schemas.openxmlformats.org/drawingml/2006/main"/>
         </p:blipFill>
@@ -18173,7 +18173,7 @@
           <p:cNvPr id="138" name="recovery-label">
             <a:extLst xmlns:a="http://schemas.openxmlformats.org/drawingml/2006/main">
               <a:ext uri="{FF2B5EF4-FFF2-40B4-BE49-F238E27FC236}">
-                <a16:creationId xmlns:a16="http://schemas.microsoft.com/office/drawing/2014/main" id="{51CA49F8-B90D-4028-83EE-8577684E8CAA}"/>
+                <a16:creationId xmlns:a16="http://schemas.microsoft.com/office/drawing/2014/main" id="{CB4700AE-A486-4874-98F0-42C2B7DC055C}"/>
               </a:ext>
             </a:extLst>
           </p:cNvPr>
@@ -18241,7 +18241,7 @@
           <p:cNvPr id="139" name="recovery-body">
             <a:extLst xmlns:a="http://schemas.openxmlformats.org/drawingml/2006/main">
               <a:ext uri="{FF2B5EF4-FFF2-40B4-BE49-F238E27FC236}">
-                <a16:creationId xmlns:a16="http://schemas.microsoft.com/office/drawing/2014/main" id="{BAC66510-A3BA-4AB0-8FE7-46E28A3C8902}"/>
+                <a16:creationId xmlns:a16="http://schemas.microsoft.com/office/drawing/2014/main" id="{581EB040-0676-4063-B681-ED4A6801603D}"/>
               </a:ext>
             </a:extLst>
           </p:cNvPr>
@@ -18457,7 +18457,7 @@
           <p:cNvPr id="140" name="recovery-foot">
             <a:extLst xmlns:a="http://schemas.openxmlformats.org/drawingml/2006/main">
               <a:ext uri="{FF2B5EF4-FFF2-40B4-BE49-F238E27FC236}">
-                <a16:creationId xmlns:a16="http://schemas.microsoft.com/office/drawing/2014/main" id="{A3D1A99D-3D39-445F-89A9-14C280B47683}"/>
+                <a16:creationId xmlns:a16="http://schemas.microsoft.com/office/drawing/2014/main" id="{EF585D1B-8238-4690-879B-3A8C646E3ECB}"/>
               </a:ext>
             </a:extLst>
           </p:cNvPr>
@@ -18523,7 +18523,7 @@
     </p:spTree>
     <p:extLst>
       <p:ext uri="{BB962C8B-B14F-4D97-AF65-F5344CB8AC3E}">
-        <p14:creationId xmlns:p14="http://schemas.microsoft.com/office/powerpoint/2010/main" val="1086194806"/>
+        <p14:creationId xmlns:p14="http://schemas.microsoft.com/office/powerpoint/2010/main" val="84798825"/>
       </p:ext>
     </p:extLst>
   </p:cSld>

</xml_diff>